<commit_message>
Module 1: student slide download now uses the final deck (notes removed)
Co-Authored-By: Claude Sonnet 5.5 <noreply@anthropic.com>
Claude-Session: https://claude.ai/code/session_01UqHdqh2796rZQzuF7uxH3N
</commit_message>
<xml_diff>
--- a/downloads/module-1-slides.pptx
+++ b/downloads/module-1-slides.pptx
@@ -4,6 +4,9 @@
   <p:sldMasterIdLst>
     <p:sldMasterId id="2147483648" r:id="rId1"/>
   </p:sldMasterIdLst>
+  <p:notesMasterIdLst>
+    <p:notesMasterId r:id="rId13"/>
+  </p:notesMasterIdLst>
   <p:sldIdLst>
     <p:sldId id="256" r:id="rId2"/>
     <p:sldId id="257" r:id="rId3"/>
@@ -17,9 +20,6 @@
     <p:sldId id="265" r:id="rId11"/>
     <p:sldId id="266" r:id="rId12"/>
   </p:sldIdLst>
-  <p:notesMasterIdLst>
-    <p:notesMasterId r:id="rId13"/>
-  </p:notesMasterIdLst>
   <p:sldSz cx="12192000" cy="6858000"/>
   <p:notesSz cx="6858000" cy="12192000"/>
   <p:defaultTextStyle>
@@ -114,7 +114,72 @@
       </a:defRPr>
     </a:lvl9pPr>
   </p:defaultTextStyle>
+  <p:extLst>
+    <p:ext uri="{EFAFB233-063F-42B5-8137-9DF3F51BA10A}">
+      <p15:sldGuideLst xmlns:p15="http://schemas.microsoft.com/office/powerpoint/2012/main"/>
+    </p:ext>
+  </p:extLst>
 </p:presentation>
+</file>
+
+<file path=ppt/changesInfos/changesInfo1.xml><?xml version="1.0" encoding="utf-8"?>
+<pc:chgInfo xmlns:a="http://schemas.openxmlformats.org/drawingml/2006/main" xmlns:r="http://schemas.openxmlformats.org/officeDocument/2006/relationships" xmlns:ac="http://schemas.microsoft.com/office/drawing/2013/main/command" xmlns:pc="http://schemas.microsoft.com/office/powerpoint/2013/main/command">
+  <pc:docChgLst>
+    <pc:chgData name="Brad Trinkle" userId="b8dd573660dcc414" providerId="LiveId" clId="{A6EA18D7-C04A-41D9-95B1-524C9F3ACE55}"/>
+    <pc:docChg chg="undo custSel modSld">
+      <pc:chgData name="Brad Trinkle" userId="b8dd573660dcc414" providerId="LiveId" clId="{A6EA18D7-C04A-41D9-95B1-524C9F3ACE55}" dt="2026-10-19T15:20:10.565" v="14" actId="1076"/>
+      <pc:docMkLst>
+        <pc:docMk/>
+      </pc:docMkLst>
+      <pc:sldChg chg="addSp delSp modSp mod">
+        <pc:chgData name="Brad Trinkle" userId="b8dd573660dcc414" providerId="LiveId" clId="{A6EA18D7-C04A-41D9-95B1-524C9F3ACE55}" dt="2026-10-19T15:17:59.597" v="6" actId="1076"/>
+        <pc:sldMkLst>
+          <pc:docMk/>
+          <pc:sldMk cId="0" sldId="262"/>
+        </pc:sldMkLst>
+        <pc:spChg chg="del">
+          <ac:chgData name="Brad Trinkle" userId="b8dd573660dcc414" providerId="LiveId" clId="{A6EA18D7-C04A-41D9-95B1-524C9F3ACE55}" dt="2026-10-19T15:17:31.249" v="0" actId="478"/>
+          <ac:spMkLst>
+            <pc:docMk/>
+            <pc:sldMk cId="0" sldId="262"/>
+            <ac:spMk id="7" creationId="{00000000-0000-0000-0000-000000000000}"/>
+          </ac:spMkLst>
+        </pc:spChg>
+        <pc:picChg chg="add mod">
+          <ac:chgData name="Brad Trinkle" userId="b8dd573660dcc414" providerId="LiveId" clId="{A6EA18D7-C04A-41D9-95B1-524C9F3ACE55}" dt="2026-10-19T15:17:59.597" v="6" actId="1076"/>
+          <ac:picMkLst>
+            <pc:docMk/>
+            <pc:sldMk cId="0" sldId="262"/>
+            <ac:picMk id="9" creationId="{84EEEAA0-4058-EC22-5BF9-262D45BD5625}"/>
+          </ac:picMkLst>
+        </pc:picChg>
+      </pc:sldChg>
+      <pc:sldChg chg="addSp delSp modSp mod">
+        <pc:chgData name="Brad Trinkle" userId="b8dd573660dcc414" providerId="LiveId" clId="{A6EA18D7-C04A-41D9-95B1-524C9F3ACE55}" dt="2026-10-19T15:20:10.565" v="14" actId="1076"/>
+        <pc:sldMkLst>
+          <pc:docMk/>
+          <pc:sldMk cId="0" sldId="263"/>
+        </pc:sldMkLst>
+        <pc:spChg chg="del">
+          <ac:chgData name="Brad Trinkle" userId="b8dd573660dcc414" providerId="LiveId" clId="{A6EA18D7-C04A-41D9-95B1-524C9F3ACE55}" dt="2026-10-19T15:19:40.270" v="7" actId="478"/>
+          <ac:spMkLst>
+            <pc:docMk/>
+            <pc:sldMk cId="0" sldId="263"/>
+            <ac:spMk id="8" creationId="{00000000-0000-0000-0000-000000000000}"/>
+          </ac:spMkLst>
+        </pc:spChg>
+        <pc:picChg chg="add mod">
+          <ac:chgData name="Brad Trinkle" userId="b8dd573660dcc414" providerId="LiveId" clId="{A6EA18D7-C04A-41D9-95B1-524C9F3ACE55}" dt="2026-10-19T15:20:10.565" v="14" actId="1076"/>
+          <ac:picMkLst>
+            <pc:docMk/>
+            <pc:sldMk cId="0" sldId="263"/>
+            <ac:picMk id="14" creationId="{D106B316-8276-5C00-263F-399428296CA8}"/>
+          </ac:picMkLst>
+        </pc:picChg>
+      </pc:sldChg>
+    </pc:docChg>
+  </pc:docChgLst>
+</pc:chgInfo>
 </file>
 
 <file path=ppt/notesMasters/notesMaster1.xml><?xml version="1.0" encoding="utf-8"?>
@@ -139,234 +204,10 @@
           <a:chExt cx="0" cy="0"/>
         </a:xfrm>
       </p:grpSpPr>
-      <p:sp>
-        <p:nvSpPr>
-          <p:cNvPr id="2" name="Header Placeholder 1"/>
-          <p:cNvSpPr>
-            <a:spLocks noGrp="1"/>
-          </p:cNvSpPr>
-          <p:nvPr>
-            <p:ph type="hdr" sz="quarter"/>
-          </p:nvPr>
-        </p:nvSpPr>
-        <p:spPr>
-          <a:xfrm>
-            <a:off x="0" y="0"/>
-            <a:ext cx="2971800" cy="458788"/>
-          </a:xfrm>
-          <a:prstGeom prst="rect">
-            <a:avLst/>
-          </a:prstGeom>
-        </p:spPr>
-        <p:txBody>
-          <a:bodyPr vert="horz" lIns="91440" tIns="45720" rIns="91440" bIns="45720" rtlCol="0"/>
-          <a:lstStyle>
-            <a:lvl1pPr algn="l">
-              <a:defRPr sz="1200"/>
-            </a:lvl1pPr>
-          </a:lstStyle>
-          <a:p>
-            <a:endParaRPr lang="en-US"/>
-          </a:p>
-        </p:txBody>
-      </p:sp>
-      <p:sp>
-        <p:nvSpPr>
-          <p:cNvPr id="3" name="Date Placeholder 2"/>
-          <p:cNvSpPr>
-            <a:spLocks noGrp="1"/>
-          </p:cNvSpPr>
-          <p:nvPr>
-            <p:ph type="dt" idx="1"/>
-          </p:nvPr>
-        </p:nvSpPr>
-        <p:spPr>
-          <a:xfrm>
-            <a:off x="3884613" y="0"/>
-            <a:ext cx="2971800" cy="458788"/>
-          </a:xfrm>
-          <a:prstGeom prst="rect">
-            <a:avLst/>
-          </a:prstGeom>
-        </p:spPr>
-        <p:txBody>
-          <a:bodyPr vert="horz" lIns="91440" tIns="45720" rIns="91440" bIns="45720" rtlCol="0"/>
-          <a:lstStyle>
-            <a:lvl1pPr algn="r">
-              <a:defRPr sz="1200"/>
-            </a:lvl1pPr>
-          </a:lstStyle>
-          <a:p>
-            <a:fld id="{5282F153-3F37-0F45-9E97-73ACFA13230C}" type="datetimeFigureOut">
-              <a:rPr lang="en-US"/>
-              <a:t>7/23/19</a:t>
-            </a:fld>
-            <a:endParaRPr lang="en-US"/>
-          </a:p>
-        </p:txBody>
-      </p:sp>
-      <p:sp>
-        <p:nvSpPr>
-          <p:cNvPr id="4" name="Slide Image Placeholder 3"/>
-          <p:cNvSpPr>
-            <a:spLocks noGrp="1" noRot="1" noChangeAspect="1"/>
-          </p:cNvSpPr>
-          <p:nvPr>
-            <p:ph type="sldImg" idx="2"/>
-          </p:nvPr>
-        </p:nvSpPr>
-        <p:spPr>
-          <a:xfrm>
-            <a:off x="685800" y="1143000"/>
-            <a:ext cx="5486400" cy="3086100"/>
-          </a:xfrm>
-          <a:prstGeom prst="rect">
-            <a:avLst/>
-          </a:prstGeom>
-          <a:noFill/>
-          <a:ln w="12700">
-            <a:solidFill>
-              <a:prstClr val="black"/>
-            </a:solidFill>
-          </a:ln>
-        </p:spPr>
-        <p:txBody>
-          <a:bodyPr vert="horz" lIns="91440" tIns="45720" rIns="91440" bIns="45720" rtlCol="0" anchor="ctr"/>
-          <a:lstStyle/>
-          <a:p>
-            <a:endParaRPr lang="en-US"/>
-          </a:p>
-        </p:txBody>
-      </p:sp>
-      <p:sp>
-        <p:nvSpPr>
-          <p:cNvPr id="5" name="Notes Placeholder 4"/>
-          <p:cNvSpPr>
-            <a:spLocks noGrp="1"/>
-          </p:cNvSpPr>
-          <p:nvPr>
-            <p:ph type="body" sz="quarter" idx="3"/>
-          </p:nvPr>
-        </p:nvSpPr>
-        <p:spPr>
-          <a:xfrm>
-            <a:off x="685800" y="4400550"/>
-            <a:ext cx="5486400" cy="3600450"/>
-          </a:xfrm>
-          <a:prstGeom prst="rect">
-            <a:avLst/>
-          </a:prstGeom>
-        </p:spPr>
-        <p:txBody>
-          <a:bodyPr vert="horz" lIns="91440" tIns="45720" rIns="91440" bIns="45720" rtlCol="0"/>
-          <a:lstStyle/>
-          <a:p>
-            <a:pPr lvl="0"/>
-            <a:r>
-              <a:rPr lang="en-US"/>
-              <a:t>Click to edit Master text styles</a:t>
-            </a:r>
-          </a:p>
-          <a:p>
-            <a:pPr lvl="1"/>
-            <a:r>
-              <a:rPr lang="en-US"/>
-              <a:t>Second level</a:t>
-            </a:r>
-          </a:p>
-          <a:p>
-            <a:pPr lvl="2"/>
-            <a:r>
-              <a:rPr lang="en-US"/>
-              <a:t>Third level</a:t>
-            </a:r>
-          </a:p>
-          <a:p>
-            <a:pPr lvl="3"/>
-            <a:r>
-              <a:rPr lang="en-US"/>
-              <a:t>Fourth level</a:t>
-            </a:r>
-          </a:p>
-          <a:p>
-            <a:pPr lvl="4"/>
-            <a:r>
-              <a:rPr lang="en-US"/>
-              <a:t>Fifth level</a:t>
-            </a:r>
-          </a:p>
-        </p:txBody>
-      </p:sp>
-      <p:sp>
-        <p:nvSpPr>
-          <p:cNvPr id="6" name="Footer Placeholder 5"/>
-          <p:cNvSpPr>
-            <a:spLocks noGrp="1"/>
-          </p:cNvSpPr>
-          <p:nvPr>
-            <p:ph type="ftr" sz="quarter" idx="4"/>
-          </p:nvPr>
-        </p:nvSpPr>
-        <p:spPr>
-          <a:xfrm>
-            <a:off x="0" y="8685213"/>
-            <a:ext cx="2971800" cy="458787"/>
-          </a:xfrm>
-          <a:prstGeom prst="rect">
-            <a:avLst/>
-          </a:prstGeom>
-        </p:spPr>
-        <p:txBody>
-          <a:bodyPr vert="horz" lIns="91440" tIns="45720" rIns="91440" bIns="45720" rtlCol="0" anchor="b"/>
-          <a:lstStyle>
-            <a:lvl1pPr algn="l">
-              <a:defRPr sz="1200"/>
-            </a:lvl1pPr>
-          </a:lstStyle>
-          <a:p>
-            <a:endParaRPr lang="en-US"/>
-          </a:p>
-        </p:txBody>
-      </p:sp>
-      <p:sp>
-        <p:nvSpPr>
-          <p:cNvPr id="7" name="Slide Number Placeholder 6"/>
-          <p:cNvSpPr>
-            <a:spLocks noGrp="1"/>
-          </p:cNvSpPr>
-          <p:nvPr>
-            <p:ph type="sldNum" sz="quarter" idx="5"/>
-          </p:nvPr>
-        </p:nvSpPr>
-        <p:spPr>
-          <a:xfrm>
-            <a:off x="3884613" y="8685213"/>
-            <a:ext cx="2971800" cy="458787"/>
-          </a:xfrm>
-          <a:prstGeom prst="rect">
-            <a:avLst/>
-          </a:prstGeom>
-        </p:spPr>
-        <p:txBody>
-          <a:bodyPr vert="horz" lIns="91440" tIns="45720" rIns="91440" bIns="45720" rtlCol="0" anchor="b"/>
-          <a:lstStyle>
-            <a:lvl1pPr algn="r">
-              <a:defRPr sz="1200"/>
-            </a:lvl1pPr>
-          </a:lstStyle>
-          <a:p>
-            <a:fld id="{CE5E9CC1-C706-0F49-92D6-E571CC5EEA8F}" type="slidenum">
-              <a:rPr lang="en-US"/>
-              <a:t>‹#›</a:t>
-            </a:fld>
-            <a:endParaRPr lang="en-US"/>
-          </a:p>
-        </p:txBody>
-      </p:sp>
     </p:spTree>
     <p:extLst>
       <p:ext uri="{BB962C8B-B14F-4D97-AF65-F5344CB8AC3E}">
-        <p14:creationId xmlns:p14="http://schemas.microsoft.com/office/powerpoint/2010/main" val="1024086991"/>
+        <p14:creationId xmlns:p14="http://schemas.microsoft.com/office/powerpoint/2010/main" val="170513079"/>
       </p:ext>
     </p:extLst>
   </p:cSld>
@@ -499,6 +340,11 @@
 <file path=ppt/slideMasters/slideMaster1.xml><?xml version="1.0" encoding="utf-8"?>
 <p:sldMaster xmlns:a="http://schemas.openxmlformats.org/drawingml/2006/main" xmlns:r="http://schemas.openxmlformats.org/officeDocument/2006/relationships" xmlns:p="http://schemas.openxmlformats.org/presentationml/2006/main">
   <p:cSld>
+    <p:bg>
+      <p:bgRef idx="1001">
+        <a:schemeClr val="bg1"/>
+      </p:bgRef>
+    </p:bg>
     <p:spTree>
       <p:nvGrpSpPr>
         <p:cNvPr id="1" name=""/>
@@ -781,6 +627,7 @@
         <a:solidFill>
           <a:srgbClr val="C8102E"/>
         </a:solidFill>
+        <a:effectLst/>
       </p:bgPr>
     </p:bg>
     <p:spTree>
@@ -818,7 +665,7 @@
           <a:bodyPr wrap="square" lIns="0" tIns="0" rIns="0" bIns="0" rtlCol="0" anchor="ctr"/>
           <a:lstStyle/>
           <a:p>
-            <a:pPr indent="0" marL="0">
+            <a:pPr marL="0" indent="0">
               <a:buNone/>
             </a:pPr>
             <a:r>
@@ -857,7 +704,7 @@
           <a:bodyPr wrap="square" lIns="0" tIns="0" rIns="0" bIns="0" rtlCol="0" anchor="ctr"/>
           <a:lstStyle/>
           <a:p>
-            <a:pPr indent="0" marL="0">
+            <a:pPr marL="0" indent="0">
               <a:buNone/>
             </a:pPr>
             <a:r>
@@ -896,7 +743,7 @@
           <a:bodyPr wrap="square" lIns="0" tIns="0" rIns="0" bIns="0" rtlCol="0" anchor="ctr"/>
           <a:lstStyle/>
           <a:p>
-            <a:pPr indent="0" marL="0">
+            <a:pPr marL="0" indent="0">
               <a:buNone/>
             </a:pPr>
             <a:r>
@@ -935,7 +782,7 @@
           <a:bodyPr wrap="square" lIns="0" tIns="0" rIns="0" bIns="0" rtlCol="0" anchor="ctr"/>
           <a:lstStyle/>
           <a:p>
-            <a:pPr indent="0" marL="0">
+            <a:pPr marL="0" indent="0">
               <a:buNone/>
             </a:pPr>
             <a:r>
@@ -974,7 +821,7 @@
           <a:bodyPr wrap="square" lIns="0" tIns="0" rIns="0" bIns="0" rtlCol="0" anchor="ctr"/>
           <a:lstStyle/>
           <a:p>
-            <a:pPr indent="0" marL="0">
+            <a:pPr marL="0" indent="0">
               <a:buNone/>
             </a:pPr>
             <a:r>
@@ -1008,6 +855,7 @@
         <a:solidFill>
           <a:srgbClr val="FBF6F0"/>
         </a:solidFill>
+        <a:effectLst/>
       </p:bgPr>
     </p:bg>
     <p:spTree>
@@ -1045,7 +893,7 @@
           <a:bodyPr wrap="square" lIns="0" tIns="0" rIns="0" bIns="0" rtlCol="0" anchor="ctr"/>
           <a:lstStyle/>
           <a:p>
-            <a:pPr indent="0" marL="0">
+            <a:pPr marL="0" indent="0">
               <a:buNone/>
             </a:pPr>
             <a:r>
@@ -1084,7 +932,7 @@
           <a:bodyPr wrap="square" lIns="0" tIns="0" rIns="0" bIns="0" rtlCol="0" anchor="ctr"/>
           <a:lstStyle/>
           <a:p>
-            <a:pPr indent="0" marL="0">
+            <a:pPr marL="0" indent="0">
               <a:buNone/>
             </a:pPr>
             <a:r>
@@ -1130,7 +978,10 @@
         </p:spPr>
         <p:txBody>
           <a:bodyPr/>
-          <a:p/>
+          <a:lstStyle/>
+          <a:p>
+            <a:endParaRPr lang="en-US"/>
+          </a:p>
         </p:txBody>
       </p:sp>
       <p:sp>
@@ -1154,7 +1005,7 @@
           <a:bodyPr wrap="square" lIns="0" tIns="0" rIns="0" bIns="0" rtlCol="0" anchor="ctr"/>
           <a:lstStyle/>
           <a:p>
-            <a:pPr algn="ctr" indent="0" marL="0">
+            <a:pPr marL="0" indent="0" algn="ctr">
               <a:buNone/>
             </a:pPr>
             <a:r>
@@ -1193,7 +1044,7 @@
           <a:bodyPr wrap="square" lIns="0" tIns="0" rIns="0" bIns="0" rtlCol="0" anchor="ctr"/>
           <a:lstStyle/>
           <a:p>
-            <a:pPr algn="ctr" indent="0" marL="0">
+            <a:pPr marL="0" indent="0" algn="ctr">
               <a:buNone/>
             </a:pPr>
             <a:r>
@@ -1239,7 +1090,10 @@
         </p:spPr>
         <p:txBody>
           <a:bodyPr/>
-          <a:p/>
+          <a:lstStyle/>
+          <a:p>
+            <a:endParaRPr lang="en-US"/>
+          </a:p>
         </p:txBody>
       </p:sp>
       <p:sp>
@@ -1263,7 +1117,7 @@
           <a:bodyPr wrap="square" lIns="0" tIns="0" rIns="0" bIns="0" rtlCol="0" anchor="ctr"/>
           <a:lstStyle/>
           <a:p>
-            <a:pPr algn="ctr" indent="0" marL="0">
+            <a:pPr marL="0" indent="0" algn="ctr">
               <a:buNone/>
             </a:pPr>
             <a:r>
@@ -1302,7 +1156,7 @@
           <a:bodyPr wrap="square" lIns="0" tIns="0" rIns="0" bIns="0" rtlCol="0" anchor="ctr"/>
           <a:lstStyle/>
           <a:p>
-            <a:pPr algn="ctr" indent="0" marL="0">
+            <a:pPr marL="0" indent="0" algn="ctr">
               <a:buNone/>
             </a:pPr>
             <a:r>
@@ -1348,7 +1202,10 @@
         </p:spPr>
         <p:txBody>
           <a:bodyPr/>
-          <a:p/>
+          <a:lstStyle/>
+          <a:p>
+            <a:endParaRPr lang="en-US"/>
+          </a:p>
         </p:txBody>
       </p:sp>
       <p:sp>
@@ -1372,7 +1229,7 @@
           <a:bodyPr wrap="square" lIns="0" tIns="0" rIns="0" bIns="0" rtlCol="0" anchor="ctr"/>
           <a:lstStyle/>
           <a:p>
-            <a:pPr algn="ctr" indent="0" marL="0">
+            <a:pPr marL="0" indent="0" algn="ctr">
               <a:buNone/>
             </a:pPr>
             <a:r>
@@ -1411,7 +1268,7 @@
           <a:bodyPr wrap="square" lIns="0" tIns="0" rIns="0" bIns="0" rtlCol="0" anchor="ctr"/>
           <a:lstStyle/>
           <a:p>
-            <a:pPr algn="ctr" indent="0" marL="0">
+            <a:pPr marL="0" indent="0" algn="ctr">
               <a:buNone/>
             </a:pPr>
             <a:r>
@@ -1457,7 +1314,10 @@
         </p:spPr>
         <p:txBody>
           <a:bodyPr/>
-          <a:p/>
+          <a:lstStyle/>
+          <a:p>
+            <a:endParaRPr lang="en-US"/>
+          </a:p>
         </p:txBody>
       </p:sp>
       <p:sp>
@@ -1481,7 +1341,7 @@
           <a:bodyPr wrap="square" lIns="0" tIns="0" rIns="0" bIns="0" rtlCol="0" anchor="ctr"/>
           <a:lstStyle/>
           <a:p>
-            <a:pPr algn="ctr" indent="0" marL="0">
+            <a:pPr marL="0" indent="0" algn="ctr">
               <a:buNone/>
             </a:pPr>
             <a:r>
@@ -1520,7 +1380,7 @@
           <a:bodyPr wrap="square" lIns="0" tIns="0" rIns="0" bIns="0" rtlCol="0" anchor="ctr"/>
           <a:lstStyle/>
           <a:p>
-            <a:pPr algn="ctr" indent="0" marL="0">
+            <a:pPr marL="0" indent="0" algn="ctr">
               <a:buNone/>
             </a:pPr>
             <a:r>
@@ -1566,7 +1426,10 @@
         </p:spPr>
         <p:txBody>
           <a:bodyPr/>
-          <a:p/>
+          <a:lstStyle/>
+          <a:p>
+            <a:endParaRPr lang="en-US"/>
+          </a:p>
         </p:txBody>
       </p:sp>
       <p:sp>
@@ -1590,7 +1453,7 @@
           <a:bodyPr wrap="square" lIns="0" tIns="0" rIns="0" bIns="0" rtlCol="0" anchor="ctr"/>
           <a:lstStyle/>
           <a:p>
-            <a:pPr algn="ctr" indent="0" marL="0">
+            <a:pPr marL="0" indent="0" algn="ctr">
               <a:buNone/>
             </a:pPr>
             <a:r>
@@ -1629,7 +1492,7 @@
           <a:bodyPr wrap="square" lIns="0" tIns="0" rIns="0" bIns="0" rtlCol="0" anchor="ctr"/>
           <a:lstStyle/>
           <a:p>
-            <a:pPr algn="ctr" indent="0" marL="0">
+            <a:pPr marL="0" indent="0" algn="ctr">
               <a:buNone/>
             </a:pPr>
             <a:r>
@@ -1668,7 +1531,7 @@
           <a:bodyPr wrap="square" lIns="0" tIns="0" rIns="0" bIns="0" rtlCol="0" anchor="ctr"/>
           <a:lstStyle/>
           <a:p>
-            <a:pPr indent="0" marL="0">
+            <a:pPr marL="0" indent="0">
               <a:buNone/>
             </a:pPr>
             <a:r>
@@ -1702,6 +1565,7 @@
         <a:solidFill>
           <a:srgbClr val="C8102E"/>
         </a:solidFill>
+        <a:effectLst/>
       </p:bgPr>
     </p:bg>
     <p:spTree>
@@ -1739,7 +1603,7 @@
           <a:bodyPr wrap="square" lIns="0" tIns="0" rIns="0" bIns="0" rtlCol="0" anchor="ctr"/>
           <a:lstStyle/>
           <a:p>
-            <a:pPr indent="0" marL="0">
+            <a:pPr marL="0" indent="0">
               <a:buNone/>
             </a:pPr>
             <a:r>
@@ -1778,7 +1642,7 @@
           <a:bodyPr wrap="square" lIns="0" tIns="0" rIns="0" bIns="0" rtlCol="0" anchor="ctr"/>
           <a:lstStyle/>
           <a:p>
-            <a:pPr indent="0" marL="0">
+            <a:pPr marL="0" indent="0">
               <a:buNone/>
             </a:pPr>
             <a:r>
@@ -1822,7 +1686,10 @@
         </p:spPr>
         <p:txBody>
           <a:bodyPr/>
-          <a:p/>
+          <a:lstStyle/>
+          <a:p>
+            <a:endParaRPr lang="en-US"/>
+          </a:p>
         </p:txBody>
       </p:sp>
       <p:sp>
@@ -1846,7 +1713,7 @@
           <a:bodyPr wrap="square" lIns="0" tIns="0" rIns="0" bIns="0" rtlCol="0" anchor="ctr"/>
           <a:lstStyle/>
           <a:p>
-            <a:pPr algn="ctr" indent="0" marL="0">
+            <a:pPr marL="0" indent="0" algn="ctr">
               <a:buNone/>
             </a:pPr>
             <a:r>
@@ -1885,7 +1752,7 @@
           <a:bodyPr wrap="square" lIns="0" tIns="0" rIns="0" bIns="0" rtlCol="0" anchor="ctr"/>
           <a:lstStyle/>
           <a:p>
-            <a:pPr algn="ctr" indent="0" marL="0">
+            <a:pPr marL="0" indent="0" algn="ctr">
               <a:buNone/>
             </a:pPr>
             <a:r>
@@ -1929,7 +1796,10 @@
         </p:spPr>
         <p:txBody>
           <a:bodyPr/>
-          <a:p/>
+          <a:lstStyle/>
+          <a:p>
+            <a:endParaRPr lang="en-US"/>
+          </a:p>
         </p:txBody>
       </p:sp>
       <p:sp>
@@ -1953,7 +1823,7 @@
           <a:bodyPr wrap="square" lIns="0" tIns="0" rIns="0" bIns="0" rtlCol="0" anchor="ctr"/>
           <a:lstStyle/>
           <a:p>
-            <a:pPr algn="ctr" indent="0" marL="0">
+            <a:pPr marL="0" indent="0" algn="ctr">
               <a:buNone/>
             </a:pPr>
             <a:r>
@@ -1992,7 +1862,7 @@
           <a:bodyPr wrap="square" lIns="0" tIns="0" rIns="0" bIns="0" rtlCol="0" anchor="ctr"/>
           <a:lstStyle/>
           <a:p>
-            <a:pPr algn="ctr" indent="0" marL="0">
+            <a:pPr marL="0" indent="0" algn="ctr">
               <a:buNone/>
             </a:pPr>
             <a:r>
@@ -2036,7 +1906,10 @@
         </p:spPr>
         <p:txBody>
           <a:bodyPr/>
-          <a:p/>
+          <a:lstStyle/>
+          <a:p>
+            <a:endParaRPr lang="en-US"/>
+          </a:p>
         </p:txBody>
       </p:sp>
       <p:sp>
@@ -2060,7 +1933,7 @@
           <a:bodyPr wrap="square" lIns="0" tIns="0" rIns="0" bIns="0" rtlCol="0" anchor="ctr"/>
           <a:lstStyle/>
           <a:p>
-            <a:pPr algn="ctr" indent="0" marL="0">
+            <a:pPr marL="0" indent="0" algn="ctr">
               <a:buNone/>
             </a:pPr>
             <a:r>
@@ -2099,7 +1972,7 @@
           <a:bodyPr wrap="square" lIns="0" tIns="0" rIns="0" bIns="0" rtlCol="0" anchor="ctr"/>
           <a:lstStyle/>
           <a:p>
-            <a:pPr algn="ctr" indent="0" marL="0">
+            <a:pPr marL="0" indent="0" algn="ctr">
               <a:buNone/>
             </a:pPr>
             <a:r>
@@ -2143,7 +2016,10 @@
         </p:spPr>
         <p:txBody>
           <a:bodyPr/>
-          <a:p/>
+          <a:lstStyle/>
+          <a:p>
+            <a:endParaRPr lang="en-US"/>
+          </a:p>
         </p:txBody>
       </p:sp>
       <p:sp>
@@ -2167,7 +2043,7 @@
           <a:bodyPr wrap="square" lIns="0" tIns="0" rIns="0" bIns="0" rtlCol="0" anchor="ctr"/>
           <a:lstStyle/>
           <a:p>
-            <a:pPr algn="ctr" indent="0" marL="0">
+            <a:pPr marL="0" indent="0" algn="ctr">
               <a:buNone/>
             </a:pPr>
             <a:r>
@@ -2206,7 +2082,7 @@
           <a:bodyPr wrap="square" lIns="0" tIns="0" rIns="0" bIns="0" rtlCol="0" anchor="ctr"/>
           <a:lstStyle/>
           <a:p>
-            <a:pPr algn="ctr" indent="0" marL="0">
+            <a:pPr marL="0" indent="0" algn="ctr">
               <a:buNone/>
             </a:pPr>
             <a:r>
@@ -2250,7 +2126,10 @@
         </p:spPr>
         <p:txBody>
           <a:bodyPr/>
-          <a:p/>
+          <a:lstStyle/>
+          <a:p>
+            <a:endParaRPr lang="en-US"/>
+          </a:p>
         </p:txBody>
       </p:sp>
       <p:sp>
@@ -2274,7 +2153,7 @@
           <a:bodyPr wrap="square" lIns="0" tIns="0" rIns="0" bIns="0" rtlCol="0" anchor="ctr"/>
           <a:lstStyle/>
           <a:p>
-            <a:pPr algn="ctr" indent="0" marL="0">
+            <a:pPr marL="0" indent="0" algn="ctr">
               <a:buNone/>
             </a:pPr>
             <a:r>
@@ -2313,7 +2192,7 @@
           <a:bodyPr wrap="square" lIns="0" tIns="0" rIns="0" bIns="0" rtlCol="0" anchor="ctr"/>
           <a:lstStyle/>
           <a:p>
-            <a:pPr algn="ctr" indent="0" marL="0">
+            <a:pPr marL="0" indent="0" algn="ctr">
               <a:buNone/>
             </a:pPr>
             <a:r>
@@ -2357,7 +2236,10 @@
         </p:spPr>
         <p:txBody>
           <a:bodyPr/>
-          <a:p/>
+          <a:lstStyle/>
+          <a:p>
+            <a:endParaRPr lang="en-US"/>
+          </a:p>
         </p:txBody>
       </p:sp>
       <p:sp>
@@ -2381,7 +2263,7 @@
           <a:bodyPr wrap="square" lIns="0" tIns="0" rIns="0" bIns="0" rtlCol="0" anchor="ctr"/>
           <a:lstStyle/>
           <a:p>
-            <a:pPr algn="ctr" indent="0" marL="0">
+            <a:pPr marL="0" indent="0" algn="ctr">
               <a:buNone/>
             </a:pPr>
             <a:r>
@@ -2420,7 +2302,7 @@
           <a:bodyPr wrap="square" lIns="0" tIns="0" rIns="0" bIns="0" rtlCol="0" anchor="ctr"/>
           <a:lstStyle/>
           <a:p>
-            <a:pPr algn="ctr" indent="0" marL="0">
+            <a:pPr marL="0" indent="0" algn="ctr">
               <a:buNone/>
             </a:pPr>
             <a:r>
@@ -2464,7 +2346,10 @@
         </p:spPr>
         <p:txBody>
           <a:bodyPr/>
-          <a:p/>
+          <a:lstStyle/>
+          <a:p>
+            <a:endParaRPr lang="en-US"/>
+          </a:p>
         </p:txBody>
       </p:sp>
       <p:sp>
@@ -2488,7 +2373,7 @@
           <a:bodyPr wrap="square" lIns="0" tIns="0" rIns="0" bIns="0" rtlCol="0" anchor="ctr"/>
           <a:lstStyle/>
           <a:p>
-            <a:pPr algn="ctr" indent="0" marL="0">
+            <a:pPr marL="0" indent="0" algn="ctr">
               <a:buNone/>
             </a:pPr>
             <a:r>
@@ -2527,7 +2412,7 @@
           <a:bodyPr wrap="square" lIns="0" tIns="0" rIns="0" bIns="0" rtlCol="0" anchor="ctr"/>
           <a:lstStyle/>
           <a:p>
-            <a:pPr algn="ctr" indent="0" marL="0">
+            <a:pPr marL="0" indent="0" algn="ctr">
               <a:buNone/>
             </a:pPr>
             <a:r>
@@ -2566,7 +2451,7 @@
           <a:bodyPr wrap="square" lIns="0" tIns="0" rIns="0" bIns="0" rtlCol="0" anchor="ctr"/>
           <a:lstStyle/>
           <a:p>
-            <a:pPr indent="0" marL="0">
+            <a:pPr marL="0" indent="0">
               <a:buNone/>
             </a:pPr>
             <a:r>
@@ -2600,6 +2485,7 @@
         <a:solidFill>
           <a:srgbClr val="FBF6F0"/>
         </a:solidFill>
+        <a:effectLst/>
       </p:bgPr>
     </p:bg>
     <p:spTree>
@@ -2637,7 +2523,7 @@
           <a:bodyPr wrap="square" lIns="0" tIns="0" rIns="0" bIns="0" rtlCol="0" anchor="ctr"/>
           <a:lstStyle/>
           <a:p>
-            <a:pPr indent="0" marL="0">
+            <a:pPr marL="0" indent="0">
               <a:buNone/>
             </a:pPr>
             <a:r>
@@ -2676,7 +2562,7 @@
           <a:bodyPr wrap="square" lIns="0" tIns="0" rIns="0" bIns="0" rtlCol="0" anchor="ctr"/>
           <a:lstStyle/>
           <a:p>
-            <a:pPr indent="0" marL="0">
+            <a:pPr marL="0" indent="0">
               <a:buNone/>
             </a:pPr>
             <a:r>
@@ -2720,7 +2606,10 @@
         </p:spPr>
         <p:txBody>
           <a:bodyPr/>
-          <a:p/>
+          <a:lstStyle/>
+          <a:p>
+            <a:endParaRPr lang="en-US"/>
+          </a:p>
         </p:txBody>
       </p:sp>
       <p:sp>
@@ -2744,7 +2633,7 @@
           <a:bodyPr wrap="square" lIns="0" tIns="0" rIns="0" bIns="0" rtlCol="0" anchor="ctr"/>
           <a:lstStyle/>
           <a:p>
-            <a:pPr indent="0" marL="0">
+            <a:pPr marL="0" indent="0">
               <a:buNone/>
             </a:pPr>
             <a:r>
@@ -2783,7 +2672,7 @@
           <a:bodyPr wrap="square" lIns="0" tIns="0" rIns="0" bIns="0" rtlCol="0" anchor="ctr"/>
           <a:lstStyle/>
           <a:p>
-            <a:pPr indent="0" marL="0">
+            <a:pPr marL="0" indent="0">
               <a:buNone/>
             </a:pPr>
             <a:r>
@@ -2822,7 +2711,7 @@
           <a:bodyPr wrap="square" lIns="0" tIns="0" rIns="0" bIns="0" rtlCol="0" anchor="ctr"/>
           <a:lstStyle/>
           <a:p>
-            <a:pPr indent="0" marL="0">
+            <a:pPr marL="0" indent="0">
               <a:buNone/>
             </a:pPr>
             <a:r>
@@ -2856,6 +2745,7 @@
         <a:solidFill>
           <a:srgbClr val="FBF6F0"/>
         </a:solidFill>
+        <a:effectLst/>
       </p:bgPr>
     </p:bg>
     <p:spTree>
@@ -2893,7 +2783,7 @@
           <a:bodyPr wrap="square" lIns="0" tIns="0" rIns="0" bIns="0" rtlCol="0" anchor="ctr"/>
           <a:lstStyle/>
           <a:p>
-            <a:pPr indent="0" marL="0">
+            <a:pPr marL="0" indent="0">
               <a:buNone/>
             </a:pPr>
             <a:r>
@@ -2932,7 +2822,7 @@
           <a:bodyPr wrap="square" lIns="0" tIns="0" rIns="0" bIns="0" rtlCol="0" anchor="ctr"/>
           <a:lstStyle/>
           <a:p>
-            <a:pPr indent="0" marL="0">
+            <a:pPr marL="0" indent="0">
               <a:buNone/>
             </a:pPr>
             <a:r>
@@ -2978,7 +2868,10 @@
         </p:spPr>
         <p:txBody>
           <a:bodyPr/>
-          <a:p/>
+          <a:lstStyle/>
+          <a:p>
+            <a:endParaRPr lang="en-US"/>
+          </a:p>
         </p:txBody>
       </p:sp>
       <p:sp>
@@ -3007,7 +2900,10 @@
         </p:spPr>
         <p:txBody>
           <a:bodyPr/>
-          <a:p/>
+          <a:lstStyle/>
+          <a:p>
+            <a:endParaRPr lang="en-US"/>
+          </a:p>
         </p:txBody>
       </p:sp>
       <p:sp>
@@ -3031,7 +2927,7 @@
           <a:bodyPr wrap="square" lIns="0" tIns="0" rIns="0" bIns="0" rtlCol="0" anchor="t"/>
           <a:lstStyle/>
           <a:p>
-            <a:pPr indent="0" marL="0">
+            <a:pPr marL="0" indent="0">
               <a:buNone/>
             </a:pPr>
             <a:r>
@@ -3070,7 +2966,7 @@
           <a:bodyPr wrap="square" lIns="0" tIns="0" rIns="0" bIns="0" rtlCol="0" anchor="t"/>
           <a:lstStyle/>
           <a:p>
-            <a:pPr indent="0" marL="0">
+            <a:pPr marL="0" indent="0">
               <a:buNone/>
             </a:pPr>
             <a:r>
@@ -3116,7 +3012,10 @@
         </p:spPr>
         <p:txBody>
           <a:bodyPr/>
-          <a:p/>
+          <a:lstStyle/>
+          <a:p>
+            <a:endParaRPr lang="en-US"/>
+          </a:p>
         </p:txBody>
       </p:sp>
       <p:sp>
@@ -3145,7 +3044,10 @@
         </p:spPr>
         <p:txBody>
           <a:bodyPr/>
-          <a:p/>
+          <a:lstStyle/>
+          <a:p>
+            <a:endParaRPr lang="en-US"/>
+          </a:p>
         </p:txBody>
       </p:sp>
       <p:sp>
@@ -3169,7 +3071,7 @@
           <a:bodyPr wrap="square" lIns="0" tIns="0" rIns="0" bIns="0" rtlCol="0" anchor="t"/>
           <a:lstStyle/>
           <a:p>
-            <a:pPr indent="0" marL="0">
+            <a:pPr marL="0" indent="0">
               <a:buNone/>
             </a:pPr>
             <a:r>
@@ -3208,7 +3110,7 @@
           <a:bodyPr wrap="square" lIns="0" tIns="0" rIns="0" bIns="0" rtlCol="0" anchor="t"/>
           <a:lstStyle/>
           <a:p>
-            <a:pPr indent="0" marL="0">
+            <a:pPr marL="0" indent="0">
               <a:buNone/>
             </a:pPr>
             <a:r>
@@ -3247,7 +3149,7 @@
           <a:bodyPr wrap="square" lIns="0" tIns="0" rIns="0" bIns="0" rtlCol="0" anchor="ctr"/>
           <a:lstStyle/>
           <a:p>
-            <a:pPr indent="0" marL="0">
+            <a:pPr marL="0" indent="0">
               <a:buNone/>
             </a:pPr>
             <a:r>
@@ -3281,6 +3183,7 @@
         <a:solidFill>
           <a:srgbClr val="FBF6F0"/>
         </a:solidFill>
+        <a:effectLst/>
       </p:bgPr>
     </p:bg>
     <p:spTree>
@@ -3318,7 +3221,7 @@
           <a:bodyPr wrap="square" lIns="0" tIns="0" rIns="0" bIns="0" rtlCol="0" anchor="ctr"/>
           <a:lstStyle/>
           <a:p>
-            <a:pPr indent="0" marL="0">
+            <a:pPr marL="0" indent="0">
               <a:buNone/>
             </a:pPr>
             <a:r>
@@ -3357,7 +3260,7 @@
           <a:bodyPr wrap="square" lIns="0" tIns="0" rIns="0" bIns="0" rtlCol="0" anchor="ctr"/>
           <a:lstStyle/>
           <a:p>
-            <a:pPr indent="0" marL="0">
+            <a:pPr marL="0" indent="0">
               <a:buNone/>
             </a:pPr>
             <a:r>
@@ -3403,7 +3306,10 @@
         </p:spPr>
         <p:txBody>
           <a:bodyPr/>
-          <a:p/>
+          <a:lstStyle/>
+          <a:p>
+            <a:endParaRPr lang="en-US"/>
+          </a:p>
         </p:txBody>
       </p:sp>
       <p:sp>
@@ -3427,7 +3333,7 @@
           <a:bodyPr wrap="square" lIns="0" tIns="0" rIns="0" bIns="0" rtlCol="0" anchor="ctr"/>
           <a:lstStyle/>
           <a:p>
-            <a:pPr algn="ctr" indent="0" marL="0">
+            <a:pPr marL="0" indent="0" algn="ctr">
               <a:buNone/>
             </a:pPr>
             <a:r>
@@ -3473,7 +3379,10 @@
         </p:spPr>
         <p:txBody>
           <a:bodyPr/>
-          <a:p/>
+          <a:lstStyle/>
+          <a:p>
+            <a:endParaRPr lang="en-US"/>
+          </a:p>
         </p:txBody>
       </p:sp>
       <p:sp>
@@ -3497,7 +3406,7 @@
           <a:bodyPr wrap="square" lIns="0" tIns="0" rIns="0" bIns="0" rtlCol="0" anchor="ctr"/>
           <a:lstStyle/>
           <a:p>
-            <a:pPr algn="ctr" indent="0" marL="0">
+            <a:pPr marL="0" indent="0" algn="ctr">
               <a:buNone/>
             </a:pPr>
             <a:r>
@@ -3543,7 +3452,10 @@
         </p:spPr>
         <p:txBody>
           <a:bodyPr/>
-          <a:p/>
+          <a:lstStyle/>
+          <a:p>
+            <a:endParaRPr lang="en-US"/>
+          </a:p>
         </p:txBody>
       </p:sp>
       <p:sp>
@@ -3567,7 +3479,7 @@
           <a:bodyPr wrap="square" lIns="0" tIns="0" rIns="0" bIns="0" rtlCol="0" anchor="ctr"/>
           <a:lstStyle/>
           <a:p>
-            <a:pPr algn="ctr" indent="0" marL="0">
+            <a:pPr marL="0" indent="0" algn="ctr">
               <a:buNone/>
             </a:pPr>
             <a:r>
@@ -3613,7 +3525,10 @@
         </p:spPr>
         <p:txBody>
           <a:bodyPr/>
-          <a:p/>
+          <a:lstStyle/>
+          <a:p>
+            <a:endParaRPr lang="en-US"/>
+          </a:p>
         </p:txBody>
       </p:sp>
       <p:sp>
@@ -3637,7 +3552,7 @@
           <a:bodyPr wrap="square" lIns="0" tIns="0" rIns="0" bIns="0" rtlCol="0" anchor="ctr"/>
           <a:lstStyle/>
           <a:p>
-            <a:pPr algn="ctr" indent="0" marL="0">
+            <a:pPr marL="0" indent="0" algn="ctr">
               <a:buNone/>
             </a:pPr>
             <a:r>
@@ -3683,7 +3598,10 @@
         </p:spPr>
         <p:txBody>
           <a:bodyPr/>
-          <a:p/>
+          <a:lstStyle/>
+          <a:p>
+            <a:endParaRPr lang="en-US"/>
+          </a:p>
         </p:txBody>
       </p:sp>
       <p:sp>
@@ -3707,7 +3625,7 @@
           <a:bodyPr wrap="square" lIns="0" tIns="0" rIns="0" bIns="0" rtlCol="0" anchor="ctr"/>
           <a:lstStyle/>
           <a:p>
-            <a:pPr algn="ctr" indent="0" marL="0">
+            <a:pPr marL="0" indent="0" algn="ctr">
               <a:buNone/>
             </a:pPr>
             <a:r>
@@ -3753,7 +3671,10 @@
         </p:spPr>
         <p:txBody>
           <a:bodyPr/>
-          <a:p/>
+          <a:lstStyle/>
+          <a:p>
+            <a:endParaRPr lang="en-US"/>
+          </a:p>
         </p:txBody>
       </p:sp>
       <p:sp>
@@ -3777,7 +3698,7 @@
           <a:bodyPr wrap="square" lIns="0" tIns="0" rIns="0" bIns="0" rtlCol="0" anchor="ctr"/>
           <a:lstStyle/>
           <a:p>
-            <a:pPr algn="ctr" indent="0" marL="0">
+            <a:pPr marL="0" indent="0" algn="ctr">
               <a:buNone/>
             </a:pPr>
             <a:r>
@@ -3811,6 +3732,7 @@
         <a:solidFill>
           <a:srgbClr val="FBF6F0"/>
         </a:solidFill>
+        <a:effectLst/>
       </p:bgPr>
     </p:bg>
     <p:spTree>
@@ -3848,7 +3770,7 @@
           <a:bodyPr wrap="square" lIns="0" tIns="0" rIns="0" bIns="0" rtlCol="0" anchor="ctr"/>
           <a:lstStyle/>
           <a:p>
-            <a:pPr indent="0" marL="0">
+            <a:pPr marL="0" indent="0">
               <a:buNone/>
             </a:pPr>
             <a:r>
@@ -3887,7 +3809,7 @@
           <a:bodyPr wrap="square" lIns="0" tIns="0" rIns="0" bIns="0" rtlCol="0" anchor="ctr"/>
           <a:lstStyle/>
           <a:p>
-            <a:pPr indent="0" marL="0">
+            <a:pPr marL="0" indent="0">
               <a:buNone/>
             </a:pPr>
             <a:r>
@@ -3933,7 +3855,10 @@
         </p:spPr>
         <p:txBody>
           <a:bodyPr/>
-          <a:p/>
+          <a:lstStyle/>
+          <a:p>
+            <a:endParaRPr lang="en-US"/>
+          </a:p>
         </p:txBody>
       </p:sp>
       <p:sp>
@@ -3962,7 +3887,10 @@
         </p:spPr>
         <p:txBody>
           <a:bodyPr/>
-          <a:p/>
+          <a:lstStyle/>
+          <a:p>
+            <a:endParaRPr lang="en-US"/>
+          </a:p>
         </p:txBody>
       </p:sp>
       <p:sp>
@@ -3986,7 +3914,7 @@
           <a:bodyPr wrap="square" lIns="0" tIns="0" rIns="0" bIns="0" rtlCol="0" anchor="t"/>
           <a:lstStyle/>
           <a:p>
-            <a:pPr indent="0" marL="0">
+            <a:pPr marL="0" indent="0">
               <a:buNone/>
             </a:pPr>
             <a:r>
@@ -4025,7 +3953,7 @@
           <a:bodyPr wrap="square" lIns="0" tIns="0" rIns="0" bIns="0" rtlCol="0" anchor="t"/>
           <a:lstStyle/>
           <a:p>
-            <a:pPr indent="0" marL="0">
+            <a:pPr marL="0" indent="0">
               <a:buNone/>
             </a:pPr>
             <a:r>
@@ -4071,7 +3999,10 @@
         </p:spPr>
         <p:txBody>
           <a:bodyPr/>
-          <a:p/>
+          <a:lstStyle/>
+          <a:p>
+            <a:endParaRPr lang="en-US"/>
+          </a:p>
         </p:txBody>
       </p:sp>
       <p:sp>
@@ -4100,7 +4031,10 @@
         </p:spPr>
         <p:txBody>
           <a:bodyPr/>
-          <a:p/>
+          <a:lstStyle/>
+          <a:p>
+            <a:endParaRPr lang="en-US"/>
+          </a:p>
         </p:txBody>
       </p:sp>
       <p:sp>
@@ -4124,7 +4058,7 @@
           <a:bodyPr wrap="square" lIns="0" tIns="0" rIns="0" bIns="0" rtlCol="0" anchor="t"/>
           <a:lstStyle/>
           <a:p>
-            <a:pPr indent="0" marL="0">
+            <a:pPr marL="0" indent="0">
               <a:buNone/>
             </a:pPr>
             <a:r>
@@ -4163,7 +4097,7 @@
           <a:bodyPr wrap="square" lIns="0" tIns="0" rIns="0" bIns="0" rtlCol="0" anchor="t"/>
           <a:lstStyle/>
           <a:p>
-            <a:pPr indent="0" marL="0">
+            <a:pPr marL="0" indent="0">
               <a:buNone/>
             </a:pPr>
             <a:r>
@@ -4209,7 +4143,10 @@
         </p:spPr>
         <p:txBody>
           <a:bodyPr/>
-          <a:p/>
+          <a:lstStyle/>
+          <a:p>
+            <a:endParaRPr lang="en-US"/>
+          </a:p>
         </p:txBody>
       </p:sp>
       <p:sp>
@@ -4238,7 +4175,10 @@
         </p:spPr>
         <p:txBody>
           <a:bodyPr/>
-          <a:p/>
+          <a:lstStyle/>
+          <a:p>
+            <a:endParaRPr lang="en-US"/>
+          </a:p>
         </p:txBody>
       </p:sp>
       <p:sp>
@@ -4262,7 +4202,7 @@
           <a:bodyPr wrap="square" lIns="0" tIns="0" rIns="0" bIns="0" rtlCol="0" anchor="t"/>
           <a:lstStyle/>
           <a:p>
-            <a:pPr indent="0" marL="0">
+            <a:pPr marL="0" indent="0">
               <a:buNone/>
             </a:pPr>
             <a:r>
@@ -4301,7 +4241,7 @@
           <a:bodyPr wrap="square" lIns="0" tIns="0" rIns="0" bIns="0" rtlCol="0" anchor="t"/>
           <a:lstStyle/>
           <a:p>
-            <a:pPr indent="0" marL="0">
+            <a:pPr marL="0" indent="0">
               <a:buNone/>
             </a:pPr>
             <a:r>
@@ -4347,7 +4287,10 @@
         </p:spPr>
         <p:txBody>
           <a:bodyPr/>
-          <a:p/>
+          <a:lstStyle/>
+          <a:p>
+            <a:endParaRPr lang="en-US"/>
+          </a:p>
         </p:txBody>
       </p:sp>
       <p:sp>
@@ -4376,7 +4319,10 @@
         </p:spPr>
         <p:txBody>
           <a:bodyPr/>
-          <a:p/>
+          <a:lstStyle/>
+          <a:p>
+            <a:endParaRPr lang="en-US"/>
+          </a:p>
         </p:txBody>
       </p:sp>
       <p:sp>
@@ -4400,7 +4346,7 @@
           <a:bodyPr wrap="square" lIns="0" tIns="0" rIns="0" bIns="0" rtlCol="0" anchor="t"/>
           <a:lstStyle/>
           <a:p>
-            <a:pPr indent="0" marL="0">
+            <a:pPr marL="0" indent="0">
               <a:buNone/>
             </a:pPr>
             <a:r>
@@ -4439,7 +4385,7 @@
           <a:bodyPr wrap="square" lIns="0" tIns="0" rIns="0" bIns="0" rtlCol="0" anchor="t"/>
           <a:lstStyle/>
           <a:p>
-            <a:pPr indent="0" marL="0">
+            <a:pPr marL="0" indent="0">
               <a:buNone/>
             </a:pPr>
             <a:r>
@@ -4478,7 +4424,7 @@
           <a:bodyPr wrap="square" lIns="0" tIns="0" rIns="0" bIns="0" rtlCol="0" anchor="ctr"/>
           <a:lstStyle/>
           <a:p>
-            <a:pPr indent="0" marL="0">
+            <a:pPr marL="0" indent="0">
               <a:buNone/>
             </a:pPr>
             <a:r>
@@ -4512,6 +4458,7 @@
         <a:solidFill>
           <a:srgbClr val="FBF6F0"/>
         </a:solidFill>
+        <a:effectLst/>
       </p:bgPr>
     </p:bg>
     <p:spTree>
@@ -4549,7 +4496,7 @@
           <a:bodyPr wrap="square" lIns="0" tIns="0" rIns="0" bIns="0" rtlCol="0" anchor="ctr"/>
           <a:lstStyle/>
           <a:p>
-            <a:pPr indent="0" marL="0">
+            <a:pPr marL="0" indent="0">
               <a:buNone/>
             </a:pPr>
             <a:r>
@@ -4588,7 +4535,7 @@
           <a:bodyPr wrap="square" lIns="0" tIns="0" rIns="0" bIns="0" rtlCol="0" anchor="ctr"/>
           <a:lstStyle/>
           <a:p>
-            <a:pPr indent="0" marL="0">
+            <a:pPr marL="0" indent="0">
               <a:buNone/>
             </a:pPr>
             <a:r>
@@ -4634,7 +4581,10 @@
         </p:spPr>
         <p:txBody>
           <a:bodyPr/>
-          <a:p/>
+          <a:lstStyle/>
+          <a:p>
+            <a:endParaRPr lang="en-US"/>
+          </a:p>
         </p:txBody>
       </p:sp>
       <p:sp>
@@ -4663,7 +4613,10 @@
         </p:spPr>
         <p:txBody>
           <a:bodyPr/>
-          <a:p/>
+          <a:lstStyle/>
+          <a:p>
+            <a:endParaRPr lang="en-US"/>
+          </a:p>
         </p:txBody>
       </p:sp>
       <p:sp>
@@ -4687,7 +4640,7 @@
           <a:bodyPr wrap="square" lIns="0" tIns="0" rIns="0" bIns="0" rtlCol="0" anchor="t"/>
           <a:lstStyle/>
           <a:p>
-            <a:pPr indent="0" marL="0">
+            <a:pPr marL="0" indent="0">
               <a:buNone/>
             </a:pPr>
             <a:r>
@@ -4726,7 +4679,7 @@
           <a:bodyPr wrap="square" lIns="0" tIns="0" rIns="0" bIns="0" rtlCol="0" anchor="t"/>
           <a:lstStyle/>
           <a:p>
-            <a:pPr indent="0" marL="0">
+            <a:pPr marL="0" indent="0">
               <a:buNone/>
             </a:pPr>
             <a:r>
@@ -4772,7 +4725,10 @@
         </p:spPr>
         <p:txBody>
           <a:bodyPr/>
-          <a:p/>
+          <a:lstStyle/>
+          <a:p>
+            <a:endParaRPr lang="en-US"/>
+          </a:p>
         </p:txBody>
       </p:sp>
       <p:sp>
@@ -4801,7 +4757,10 @@
         </p:spPr>
         <p:txBody>
           <a:bodyPr/>
-          <a:p/>
+          <a:lstStyle/>
+          <a:p>
+            <a:endParaRPr lang="en-US"/>
+          </a:p>
         </p:txBody>
       </p:sp>
       <p:sp>
@@ -4825,7 +4784,7 @@
           <a:bodyPr wrap="square" lIns="0" tIns="0" rIns="0" bIns="0" rtlCol="0" anchor="t"/>
           <a:lstStyle/>
           <a:p>
-            <a:pPr indent="0" marL="0">
+            <a:pPr marL="0" indent="0">
               <a:buNone/>
             </a:pPr>
             <a:r>
@@ -4864,7 +4823,7 @@
           <a:bodyPr wrap="square" lIns="0" tIns="0" rIns="0" bIns="0" rtlCol="0" anchor="t"/>
           <a:lstStyle/>
           <a:p>
-            <a:pPr indent="0" marL="0">
+            <a:pPr marL="0" indent="0">
               <a:buNone/>
             </a:pPr>
             <a:r>
@@ -4910,7 +4869,10 @@
         </p:spPr>
         <p:txBody>
           <a:bodyPr/>
-          <a:p/>
+          <a:lstStyle/>
+          <a:p>
+            <a:endParaRPr lang="en-US"/>
+          </a:p>
         </p:txBody>
       </p:sp>
       <p:sp>
@@ -4939,7 +4901,10 @@
         </p:spPr>
         <p:txBody>
           <a:bodyPr/>
-          <a:p/>
+          <a:lstStyle/>
+          <a:p>
+            <a:endParaRPr lang="en-US"/>
+          </a:p>
         </p:txBody>
       </p:sp>
       <p:sp>
@@ -4963,7 +4928,7 @@
           <a:bodyPr wrap="square" lIns="0" tIns="0" rIns="0" bIns="0" rtlCol="0" anchor="t"/>
           <a:lstStyle/>
           <a:p>
-            <a:pPr indent="0" marL="0">
+            <a:pPr marL="0" indent="0">
               <a:buNone/>
             </a:pPr>
             <a:r>
@@ -5002,7 +4967,7 @@
           <a:bodyPr wrap="square" lIns="0" tIns="0" rIns="0" bIns="0" rtlCol="0" anchor="t"/>
           <a:lstStyle/>
           <a:p>
-            <a:pPr indent="0" marL="0">
+            <a:pPr marL="0" indent="0">
               <a:buNone/>
             </a:pPr>
             <a:r>
@@ -5041,7 +5006,7 @@
           <a:bodyPr wrap="square" lIns="0" tIns="0" rIns="0" bIns="0" rtlCol="0" anchor="ctr"/>
           <a:lstStyle/>
           <a:p>
-            <a:pPr indent="0" marL="0">
+            <a:pPr marL="0" indent="0">
               <a:buNone/>
             </a:pPr>
             <a:r>
@@ -5075,6 +5040,7 @@
         <a:solidFill>
           <a:srgbClr val="FBF6F0"/>
         </a:solidFill>
+        <a:effectLst/>
       </p:bgPr>
     </p:bg>
     <p:spTree>
@@ -5112,7 +5078,7 @@
           <a:bodyPr wrap="square" lIns="0" tIns="0" rIns="0" bIns="0" rtlCol="0" anchor="ctr"/>
           <a:lstStyle/>
           <a:p>
-            <a:pPr indent="0" marL="0">
+            <a:pPr marL="0" indent="0">
               <a:buNone/>
             </a:pPr>
             <a:r>
@@ -5151,7 +5117,7 @@
           <a:bodyPr wrap="square" lIns="0" tIns="0" rIns="0" bIns="0" rtlCol="0" anchor="ctr"/>
           <a:lstStyle/>
           <a:p>
-            <a:pPr indent="0" marL="0">
+            <a:pPr marL="0" indent="0">
               <a:buNone/>
             </a:pPr>
             <a:r>
@@ -5190,7 +5156,7 @@
           <a:bodyPr wrap="square" lIns="0" tIns="0" rIns="0" bIns="0" rtlCol="0" anchor="ctr"/>
           <a:lstStyle/>
           <a:p>
-            <a:pPr indent="0" marL="0">
+            <a:pPr marL="0" indent="0">
               <a:buNone/>
             </a:pPr>
             <a:r>
@@ -5236,93 +5202,81 @@
         </p:spPr>
         <p:txBody>
           <a:bodyPr/>
-          <a:p/>
-        </p:txBody>
-      </p:sp>
-      <p:sp>
-        <p:nvSpPr>
-          <p:cNvPr id="7" name="Text 4"/>
-          <p:cNvSpPr txBox="1"/>
-          <p:nvPr/>
-        </p:nvSpPr>
-        <p:spPr>
-          <a:xfrm>
-            <a:off x="822960" y="2331720"/>
-            <a:ext cx="10515600" cy="2834640"/>
-          </a:xfrm>
-          <a:prstGeom prst="rect">
-            <a:avLst/>
-          </a:prstGeom>
-          <a:noFill/>
-          <a:ln/>
-        </p:spPr>
-        <p:txBody>
-          <a:bodyPr wrap="square" lIns="0" tIns="0" rIns="0" bIns="0" rtlCol="0" anchor="t"/>
-          <a:lstStyle/>
-          <a:p>
-            <a:pPr indent="0" marL="0">
-              <a:buNone/>
-            </a:pPr>
-            <a:endParaRPr lang="en-US" sz="2000" dirty="0"/>
-          </a:p>
-          <a:p>
-            <a:pPr indent="0" marL="0">
-              <a:buNone/>
-            </a:pPr>
-            <a:r>
-              <a:rPr lang="en-US" sz="2000" dirty="0">
-                <a:solidFill>
-                  <a:srgbClr val="2B2B2B"/>
+          <a:lstStyle/>
+          <a:p>
+            <a:endParaRPr lang="en-US"/>
+          </a:p>
+        </p:txBody>
+      </p:sp>
+      <p:sp>
+        <p:nvSpPr>
+          <p:cNvPr id="8" name="Text 5"/>
+          <p:cNvSpPr txBox="1"/>
+          <p:nvPr/>
+        </p:nvSpPr>
+        <p:spPr>
+          <a:xfrm>
+            <a:off x="548640" y="5577840"/>
+            <a:ext cx="10972800" cy="457200"/>
+          </a:xfrm>
+          <a:prstGeom prst="rect">
+            <a:avLst/>
+          </a:prstGeom>
+          <a:noFill/>
+          <a:ln/>
+        </p:spPr>
+        <p:txBody>
+          <a:bodyPr wrap="square" lIns="0" tIns="0" rIns="0" bIns="0" rtlCol="0" anchor="ctr"/>
+          <a:lstStyle/>
+          <a:p>
+            <a:pPr marL="0" indent="0">
+              <a:buNone/>
+            </a:pPr>
+            <a:r>
+              <a:rPr lang="en-US" sz="1800" b="1" dirty="0">
+                <a:solidFill>
+                  <a:srgbClr val="C8102E"/>
                 </a:solidFill>
                 <a:latin typeface="Calibri" pitchFamily="34" charset="0"/>
                 <a:ea typeface="Calibri" pitchFamily="34" charset="-122"/>
                 <a:cs typeface="Calibri" pitchFamily="34" charset="-120"/>
               </a:rPr>
-              <a:t>Prompt used: “You’re helping the Velox Controller review travel spending. From the attached file, list every expense over $5,000 with the employee’s department, the amount, and the purpose. Then total them by department, and flag anything that looks unusual.”</a:t>
-            </a:r>
-            <a:endParaRPr lang="en-US" sz="2000" dirty="0"/>
-          </a:p>
-        </p:txBody>
-      </p:sp>
-      <p:sp>
-        <p:nvSpPr>
-          <p:cNvPr id="8" name="Text 5"/>
-          <p:cNvSpPr txBox="1"/>
-          <p:nvPr/>
-        </p:nvSpPr>
-        <p:spPr>
-          <a:xfrm>
-            <a:off x="548640" y="5577840"/>
-            <a:ext cx="10972800" cy="457200"/>
-          </a:xfrm>
-          <a:prstGeom prst="rect">
-            <a:avLst/>
-          </a:prstGeom>
-          <a:noFill/>
-          <a:ln/>
-        </p:spPr>
-        <p:txBody>
-          <a:bodyPr wrap="square" lIns="0" tIns="0" rIns="0" bIns="0" rtlCol="0" anchor="ctr"/>
-          <a:lstStyle/>
-          <a:p>
-            <a:pPr indent="0" marL="0">
-              <a:buNone/>
-            </a:pPr>
-            <a:r>
-              <a:rPr lang="en-US" sz="1800" b="1" dirty="0">
-                <a:solidFill>
-                  <a:srgbClr val="C8102E"/>
-                </a:solidFill>
-                <a:latin typeface="Calibri" pitchFamily="34" charset="0"/>
-                <a:ea typeface="Calibri" pitchFamily="34" charset="-122"/>
-                <a:cs typeface="Calibri" pitchFamily="34" charset="-120"/>
-              </a:rPr>
               <a:t>Named the audience, the threshold, the fields, and what to flag.</a:t>
             </a:r>
             <a:endParaRPr lang="en-US" sz="1800" dirty="0"/>
           </a:p>
         </p:txBody>
       </p:sp>
+      <p:pic>
+        <p:nvPicPr>
+          <p:cNvPr id="9" name="Picture 8">
+            <a:extLst>
+              <a:ext uri="{FF2B5EF4-FFF2-40B4-BE49-F238E27FC236}">
+                <a16:creationId xmlns:a16="http://schemas.microsoft.com/office/drawing/2014/main" id="{84EEEAA0-4058-EC22-5BF9-262D45BD5625}"/>
+              </a:ext>
+            </a:extLst>
+          </p:cNvPr>
+          <p:cNvPicPr>
+            <a:picLocks noChangeAspect="1"/>
+          </p:cNvPicPr>
+          <p:nvPr/>
+        </p:nvPicPr>
+        <p:blipFill>
+          <a:blip r:embed="rId3"/>
+          <a:stretch>
+            <a:fillRect/>
+          </a:stretch>
+        </p:blipFill>
+        <p:spPr>
+          <a:xfrm>
+            <a:off x="906584" y="2286000"/>
+            <a:ext cx="9886461" cy="2934710"/>
+          </a:xfrm>
+          <a:prstGeom prst="rect">
+            <a:avLst/>
+          </a:prstGeom>
+        </p:spPr>
+      </p:pic>
     </p:spTree>
   </p:cSld>
   <p:clrMapOvr>
@@ -5339,6 +5293,7 @@
         <a:solidFill>
           <a:srgbClr val="FBF6F0"/>
         </a:solidFill>
+        <a:effectLst/>
       </p:bgPr>
     </p:bg>
     <p:spTree>
@@ -5376,7 +5331,7 @@
           <a:bodyPr wrap="square" lIns="0" tIns="0" rIns="0" bIns="0" rtlCol="0" anchor="ctr"/>
           <a:lstStyle/>
           <a:p>
-            <a:pPr indent="0" marL="0">
+            <a:pPr marL="0" indent="0">
               <a:buNone/>
             </a:pPr>
             <a:r>
@@ -5415,7 +5370,7 @@
           <a:bodyPr wrap="square" lIns="0" tIns="0" rIns="0" bIns="0" rtlCol="0" anchor="ctr"/>
           <a:lstStyle/>
           <a:p>
-            <a:pPr indent="0" marL="0">
+            <a:pPr marL="0" indent="0">
               <a:buNone/>
             </a:pPr>
             <a:r>
@@ -5461,7 +5416,10 @@
         </p:spPr>
         <p:txBody>
           <a:bodyPr/>
-          <a:p/>
+          <a:lstStyle/>
+          <a:p>
+            <a:endParaRPr lang="en-US" dirty="0"/>
+          </a:p>
         </p:txBody>
       </p:sp>
       <p:sp>
@@ -5490,7 +5448,10 @@
         </p:spPr>
         <p:txBody>
           <a:bodyPr/>
-          <a:p/>
+          <a:lstStyle/>
+          <a:p>
+            <a:endParaRPr lang="en-US"/>
+          </a:p>
         </p:txBody>
       </p:sp>
       <p:sp>
@@ -5514,7 +5475,7 @@
           <a:bodyPr wrap="square" lIns="0" tIns="0" rIns="0" bIns="0" rtlCol="0" anchor="t"/>
           <a:lstStyle/>
           <a:p>
-            <a:pPr indent="0" marL="0">
+            <a:pPr marL="0" indent="0">
               <a:buNone/>
             </a:pPr>
             <a:r>
@@ -5529,45 +5490,6 @@
               <a:t>AI’s answer</a:t>
             </a:r>
             <a:endParaRPr lang="en-US" sz="2600" dirty="0"/>
-          </a:p>
-        </p:txBody>
-      </p:sp>
-      <p:sp>
-        <p:nvSpPr>
-          <p:cNvPr id="8" name="Text 5"/>
-          <p:cNvSpPr txBox="1"/>
-          <p:nvPr/>
-        </p:nvSpPr>
-        <p:spPr>
-          <a:xfrm>
-            <a:off x="822960" y="2606040"/>
-            <a:ext cx="4846320" cy="2377440"/>
-          </a:xfrm>
-          <a:prstGeom prst="rect">
-            <a:avLst/>
-          </a:prstGeom>
-          <a:noFill/>
-          <a:ln/>
-        </p:spPr>
-        <p:txBody>
-          <a:bodyPr wrap="square" lIns="0" tIns="0" rIns="0" bIns="0" rtlCol="0" anchor="t"/>
-          <a:lstStyle/>
-          <a:p>
-            <a:pPr indent="0" marL="0">
-              <a:buNone/>
-            </a:pPr>
-            <a:r>
-              <a:rPr lang="en-US" sz="2100" dirty="0">
-                <a:solidFill>
-                  <a:srgbClr val="2B2B2B"/>
-                </a:solidFill>
-                <a:latin typeface="Calibri" pitchFamily="34" charset="0"/>
-                <a:ea typeface="Calibri" pitchFamily="34" charset="-122"/>
-                <a:cs typeface="Calibri" pitchFamily="34" charset="-120"/>
-              </a:rPr>
-              <a:t>In a test run: a list of 14 expenses over $5,000, totals by department, and flags.</a:t>
-            </a:r>
-            <a:endParaRPr lang="en-US" sz="2100" dirty="0"/>
           </a:p>
         </p:txBody>
       </p:sp>
@@ -5599,7 +5521,10 @@
         </p:spPr>
         <p:txBody>
           <a:bodyPr/>
-          <a:p/>
+          <a:lstStyle/>
+          <a:p>
+            <a:endParaRPr lang="en-US"/>
+          </a:p>
         </p:txBody>
       </p:sp>
       <p:sp>
@@ -5628,7 +5553,10 @@
         </p:spPr>
         <p:txBody>
           <a:bodyPr/>
-          <a:p/>
+          <a:lstStyle/>
+          <a:p>
+            <a:endParaRPr lang="en-US"/>
+          </a:p>
         </p:txBody>
       </p:sp>
       <p:sp>
@@ -5652,7 +5580,7 @@
           <a:bodyPr wrap="square" lIns="0" tIns="0" rIns="0" bIns="0" rtlCol="0" anchor="t"/>
           <a:lstStyle/>
           <a:p>
-            <a:pPr indent="0" marL="0">
+            <a:pPr marL="0" indent="0">
               <a:buNone/>
             </a:pPr>
             <a:r>
@@ -5691,7 +5619,7 @@
           <a:bodyPr wrap="square" lIns="0" tIns="0" rIns="0" bIns="0" rtlCol="0" anchor="t"/>
           <a:lstStyle/>
           <a:p>
-            <a:pPr indent="0" marL="0">
+            <a:pPr marL="0" indent="0">
               <a:buNone/>
             </a:pPr>
             <a:r>
@@ -5730,7 +5658,7 @@
           <a:bodyPr wrap="square" lIns="0" tIns="0" rIns="0" bIns="0" rtlCol="0" anchor="ctr"/>
           <a:lstStyle/>
           <a:p>
-            <a:pPr indent="0" marL="0">
+            <a:pPr marL="0" indent="0">
               <a:buNone/>
             </a:pPr>
             <a:r>
@@ -5748,6 +5676,36 @@
           </a:p>
         </p:txBody>
       </p:sp>
+      <p:pic>
+        <p:nvPicPr>
+          <p:cNvPr id="14" name="Picture 13">
+            <a:extLst>
+              <a:ext uri="{FF2B5EF4-FFF2-40B4-BE49-F238E27FC236}">
+                <a16:creationId xmlns:a16="http://schemas.microsoft.com/office/drawing/2014/main" id="{D106B316-8276-5C00-263F-399428296CA8}"/>
+              </a:ext>
+            </a:extLst>
+          </p:cNvPr>
+          <p:cNvPicPr>
+            <a:picLocks noChangeAspect="1"/>
+          </p:cNvPicPr>
+          <p:nvPr/>
+        </p:nvPicPr>
+        <p:blipFill>
+          <a:blip r:embed="rId3"/>
+          <a:stretch>
+            <a:fillRect/>
+          </a:stretch>
+        </p:blipFill>
+        <p:spPr>
+          <a:xfrm>
+            <a:off x="1342058" y="2415046"/>
+            <a:ext cx="3256671" cy="2550867"/>
+          </a:xfrm>
+          <a:prstGeom prst="rect">
+            <a:avLst/>
+          </a:prstGeom>
+        </p:spPr>
+      </p:pic>
     </p:spTree>
   </p:cSld>
   <p:clrMapOvr>
@@ -5764,6 +5722,7 @@
         <a:solidFill>
           <a:srgbClr val="FBF6F0"/>
         </a:solidFill>
+        <a:effectLst/>
       </p:bgPr>
     </p:bg>
     <p:spTree>
@@ -5801,7 +5760,7 @@
           <a:bodyPr wrap="square" lIns="0" tIns="0" rIns="0" bIns="0" rtlCol="0" anchor="ctr"/>
           <a:lstStyle/>
           <a:p>
-            <a:pPr indent="0" marL="0">
+            <a:pPr marL="0" indent="0">
               <a:buNone/>
             </a:pPr>
             <a:r>
@@ -5840,7 +5799,7 @@
           <a:bodyPr wrap="square" lIns="0" tIns="0" rIns="0" bIns="0" rtlCol="0" anchor="ctr"/>
           <a:lstStyle/>
           <a:p>
-            <a:pPr indent="0" marL="0">
+            <a:pPr marL="0" indent="0">
               <a:buNone/>
             </a:pPr>
             <a:r>
@@ -5886,7 +5845,10 @@
         </p:spPr>
         <p:txBody>
           <a:bodyPr/>
-          <a:p/>
+          <a:lstStyle/>
+          <a:p>
+            <a:endParaRPr lang="en-US"/>
+          </a:p>
         </p:txBody>
       </p:sp>
       <p:sp>
@@ -5915,7 +5877,10 @@
         </p:spPr>
         <p:txBody>
           <a:bodyPr/>
-          <a:p/>
+          <a:lstStyle/>
+          <a:p>
+            <a:endParaRPr lang="en-US"/>
+          </a:p>
         </p:txBody>
       </p:sp>
       <p:sp>
@@ -5939,7 +5904,7 @@
           <a:bodyPr wrap="square" lIns="0" tIns="0" rIns="0" bIns="0" rtlCol="0" anchor="t"/>
           <a:lstStyle/>
           <a:p>
-            <a:pPr indent="0" marL="0">
+            <a:pPr marL="0" indent="0">
               <a:buNone/>
             </a:pPr>
             <a:r>
@@ -5978,7 +5943,7 @@
           <a:bodyPr wrap="square" lIns="0" tIns="0" rIns="0" bIns="0" rtlCol="0" anchor="t"/>
           <a:lstStyle/>
           <a:p>
-            <a:pPr indent="0" marL="0">
+            <a:pPr marL="0" indent="0">
               <a:buNone/>
             </a:pPr>
             <a:r>
@@ -6024,7 +5989,10 @@
         </p:spPr>
         <p:txBody>
           <a:bodyPr/>
-          <a:p/>
+          <a:lstStyle/>
+          <a:p>
+            <a:endParaRPr lang="en-US"/>
+          </a:p>
         </p:txBody>
       </p:sp>
       <p:sp>
@@ -6048,7 +6016,7 @@
           <a:bodyPr wrap="square" lIns="0" tIns="0" rIns="0" bIns="0" rtlCol="0" anchor="ctr"/>
           <a:lstStyle/>
           <a:p>
-            <a:pPr algn="ctr" indent="0" marL="0">
+            <a:pPr marL="0" indent="0" algn="ctr">
               <a:buNone/>
             </a:pPr>
             <a:r>
@@ -6094,7 +6062,10 @@
         </p:spPr>
         <p:txBody>
           <a:bodyPr/>
-          <a:p/>
+          <a:lstStyle/>
+          <a:p>
+            <a:endParaRPr lang="en-US"/>
+          </a:p>
         </p:txBody>
       </p:sp>
       <p:sp>
@@ -6118,7 +6089,7 @@
           <a:bodyPr wrap="square" lIns="0" tIns="0" rIns="0" bIns="0" rtlCol="0" anchor="ctr"/>
           <a:lstStyle/>
           <a:p>
-            <a:pPr algn="ctr" indent="0" marL="0">
+            <a:pPr marL="0" indent="0" algn="ctr">
               <a:buNone/>
             </a:pPr>
             <a:r>
@@ -6164,7 +6135,10 @@
         </p:spPr>
         <p:txBody>
           <a:bodyPr/>
-          <a:p/>
+          <a:lstStyle/>
+          <a:p>
+            <a:endParaRPr lang="en-US"/>
+          </a:p>
         </p:txBody>
       </p:sp>
       <p:sp>
@@ -6188,7 +6162,7 @@
           <a:bodyPr wrap="square" lIns="0" tIns="0" rIns="0" bIns="0" rtlCol="0" anchor="ctr"/>
           <a:lstStyle/>
           <a:p>
-            <a:pPr algn="ctr" indent="0" marL="0">
+            <a:pPr marL="0" indent="0" algn="ctr">
               <a:buNone/>
             </a:pPr>
             <a:r>
@@ -6227,7 +6201,7 @@
           <a:bodyPr wrap="square" lIns="0" tIns="0" rIns="0" bIns="0" rtlCol="0" anchor="ctr"/>
           <a:lstStyle/>
           <a:p>
-            <a:pPr indent="0" marL="0">
+            <a:pPr marL="0" indent="0">
               <a:buNone/>
             </a:pPr>
             <a:r>
@@ -6546,4 +6520,319 @@
     </a:ext>
   </a:extLst>
 </a:theme>
+</file>
+
+<file path=ppt/theme/theme2.xml><?xml version="1.0" encoding="utf-8"?>
+<a:theme xmlns:a="http://schemas.openxmlformats.org/drawingml/2006/main" name="Office Theme">
+  <a:themeElements>
+    <a:clrScheme name="Office">
+      <a:dk1>
+        <a:sysClr val="windowText" lastClr="000000"/>
+      </a:dk1>
+      <a:lt1>
+        <a:sysClr val="window" lastClr="FFFFFF"/>
+      </a:lt1>
+      <a:dk2>
+        <a:srgbClr val="0E2841"/>
+      </a:dk2>
+      <a:lt2>
+        <a:srgbClr val="E8E8E8"/>
+      </a:lt2>
+      <a:accent1>
+        <a:srgbClr val="156082"/>
+      </a:accent1>
+      <a:accent2>
+        <a:srgbClr val="E97132"/>
+      </a:accent2>
+      <a:accent3>
+        <a:srgbClr val="196B24"/>
+      </a:accent3>
+      <a:accent4>
+        <a:srgbClr val="0F9ED5"/>
+      </a:accent4>
+      <a:accent5>
+        <a:srgbClr val="A02B93"/>
+      </a:accent5>
+      <a:accent6>
+        <a:srgbClr val="4EA72E"/>
+      </a:accent6>
+      <a:hlink>
+        <a:srgbClr val="467886"/>
+      </a:hlink>
+      <a:folHlink>
+        <a:srgbClr val="96607D"/>
+      </a:folHlink>
+    </a:clrScheme>
+    <a:fontScheme name="Office">
+      <a:majorFont>
+        <a:latin typeface="Aptos Display" panose="02110004020202020204"/>
+        <a:ea typeface=""/>
+        <a:cs typeface=""/>
+        <a:font script="Jpan" typeface="游ゴシック Light"/>
+        <a:font script="Hang" typeface="맑은 고딕"/>
+        <a:font script="Hans" typeface="等线 Light"/>
+        <a:font script="Hant" typeface="新細明體"/>
+        <a:font script="Arab" typeface="Times New Roman"/>
+        <a:font script="Hebr" typeface="Times New Roman"/>
+        <a:font script="Thai" typeface="Angsana New"/>
+        <a:font script="Ethi" typeface="Nyala"/>
+        <a:font script="Beng" typeface="Vrinda"/>
+        <a:font script="Gujr" typeface="Shruti"/>
+        <a:font script="Khmr" typeface="MoolBoran"/>
+        <a:font script="Knda" typeface="Tunga"/>
+        <a:font script="Guru" typeface="Raavi"/>
+        <a:font script="Cans" typeface="Euphemia"/>
+        <a:font script="Cher" typeface="Plantagenet Cherokee"/>
+        <a:font script="Yiii" typeface="Microsoft Yi Baiti"/>
+        <a:font script="Tibt" typeface="Microsoft Himalaya"/>
+        <a:font script="Thaa" typeface="MV Boli"/>
+        <a:font script="Deva" typeface="Mangal"/>
+        <a:font script="Telu" typeface="Gautami"/>
+        <a:font script="Taml" typeface="Latha"/>
+        <a:font script="Syrc" typeface="Estrangelo Edessa"/>
+        <a:font script="Orya" typeface="Kalinga"/>
+        <a:font script="Mlym" typeface="Kartika"/>
+        <a:font script="Laoo" typeface="DokChampa"/>
+        <a:font script="Sinh" typeface="Iskoola Pota"/>
+        <a:font script="Mong" typeface="Mongolian Baiti"/>
+        <a:font script="Viet" typeface="Times New Roman"/>
+        <a:font script="Uigh" typeface="Microsoft Uighur"/>
+        <a:font script="Geor" typeface="Sylfaen"/>
+        <a:font script="Armn" typeface="Arial"/>
+        <a:font script="Bugi" typeface="Leelawadee UI"/>
+        <a:font script="Bopo" typeface="Microsoft JhengHei"/>
+        <a:font script="Java" typeface="Javanese Text"/>
+        <a:font script="Lisu" typeface="Segoe UI"/>
+        <a:font script="Mymr" typeface="Myanmar Text"/>
+        <a:font script="Nkoo" typeface="Ebrima"/>
+        <a:font script="Olck" typeface="Nirmala UI"/>
+        <a:font script="Osma" typeface="Ebrima"/>
+        <a:font script="Phag" typeface="Phagspa"/>
+        <a:font script="Syrn" typeface="Estrangelo Edessa"/>
+        <a:font script="Syrj" typeface="Estrangelo Edessa"/>
+        <a:font script="Syre" typeface="Estrangelo Edessa"/>
+        <a:font script="Sora" typeface="Nirmala UI"/>
+        <a:font script="Tale" typeface="Microsoft Tai Le"/>
+        <a:font script="Talu" typeface="Microsoft New Tai Lue"/>
+        <a:font script="Tfng" typeface="Ebrima"/>
+      </a:majorFont>
+      <a:minorFont>
+        <a:latin typeface="Aptos" panose="02110004020202020204"/>
+        <a:ea typeface=""/>
+        <a:cs typeface=""/>
+        <a:font script="Jpan" typeface="游ゴシック"/>
+        <a:font script="Hang" typeface="맑은 고딕"/>
+        <a:font script="Hans" typeface="等线"/>
+        <a:font script="Hant" typeface="新細明體"/>
+        <a:font script="Arab" typeface="Arial"/>
+        <a:font script="Hebr" typeface="Arial"/>
+        <a:font script="Thai" typeface="Cordia New"/>
+        <a:font script="Ethi" typeface="Nyala"/>
+        <a:font script="Beng" typeface="Vrinda"/>
+        <a:font script="Gujr" typeface="Shruti"/>
+        <a:font script="Khmr" typeface="DaunPenh"/>
+        <a:font script="Knda" typeface="Tunga"/>
+        <a:font script="Guru" typeface="Raavi"/>
+        <a:font script="Cans" typeface="Euphemia"/>
+        <a:font script="Cher" typeface="Plantagenet Cherokee"/>
+        <a:font script="Yiii" typeface="Microsoft Yi Baiti"/>
+        <a:font script="Tibt" typeface="Microsoft Himalaya"/>
+        <a:font script="Thaa" typeface="MV Boli"/>
+        <a:font script="Deva" typeface="Mangal"/>
+        <a:font script="Telu" typeface="Gautami"/>
+        <a:font script="Taml" typeface="Latha"/>
+        <a:font script="Syrc" typeface="Estrangelo Edessa"/>
+        <a:font script="Orya" typeface="Kalinga"/>
+        <a:font script="Mlym" typeface="Kartika"/>
+        <a:font script="Laoo" typeface="DokChampa"/>
+        <a:font script="Sinh" typeface="Iskoola Pota"/>
+        <a:font script="Mong" typeface="Mongolian Baiti"/>
+        <a:font script="Viet" typeface="Arial"/>
+        <a:font script="Uigh" typeface="Microsoft Uighur"/>
+        <a:font script="Geor" typeface="Sylfaen"/>
+        <a:font script="Armn" typeface="Arial"/>
+        <a:font script="Bugi" typeface="Leelawadee UI"/>
+        <a:font script="Bopo" typeface="Microsoft JhengHei"/>
+        <a:font script="Java" typeface="Javanese Text"/>
+        <a:font script="Lisu" typeface="Segoe UI"/>
+        <a:font script="Mymr" typeface="Myanmar Text"/>
+        <a:font script="Nkoo" typeface="Ebrima"/>
+        <a:font script="Olck" typeface="Nirmala UI"/>
+        <a:font script="Osma" typeface="Ebrima"/>
+        <a:font script="Phag" typeface="Phagspa"/>
+        <a:font script="Syrn" typeface="Estrangelo Edessa"/>
+        <a:font script="Syrj" typeface="Estrangelo Edessa"/>
+        <a:font script="Syre" typeface="Estrangelo Edessa"/>
+        <a:font script="Sora" typeface="Nirmala UI"/>
+        <a:font script="Tale" typeface="Microsoft Tai Le"/>
+        <a:font script="Talu" typeface="Microsoft New Tai Lue"/>
+        <a:font script="Tfng" typeface="Ebrima"/>
+      </a:minorFont>
+    </a:fontScheme>
+    <a:fmtScheme name="Office">
+      <a:fillStyleLst>
+        <a:solidFill>
+          <a:schemeClr val="phClr"/>
+        </a:solidFill>
+        <a:gradFill rotWithShape="1">
+          <a:gsLst>
+            <a:gs pos="0">
+              <a:schemeClr val="phClr">
+                <a:lumMod val="110000"/>
+                <a:satMod val="105000"/>
+                <a:tint val="67000"/>
+              </a:schemeClr>
+            </a:gs>
+            <a:gs pos="50000">
+              <a:schemeClr val="phClr">
+                <a:lumMod val="105000"/>
+                <a:satMod val="103000"/>
+                <a:tint val="73000"/>
+              </a:schemeClr>
+            </a:gs>
+            <a:gs pos="100000">
+              <a:schemeClr val="phClr">
+                <a:lumMod val="105000"/>
+                <a:satMod val="109000"/>
+                <a:tint val="81000"/>
+              </a:schemeClr>
+            </a:gs>
+          </a:gsLst>
+          <a:lin ang="5400000" scaled="0"/>
+        </a:gradFill>
+        <a:gradFill rotWithShape="1">
+          <a:gsLst>
+            <a:gs pos="0">
+              <a:schemeClr val="phClr">
+                <a:satMod val="103000"/>
+                <a:lumMod val="102000"/>
+                <a:tint val="94000"/>
+              </a:schemeClr>
+            </a:gs>
+            <a:gs pos="50000">
+              <a:schemeClr val="phClr">
+                <a:satMod val="110000"/>
+                <a:lumMod val="100000"/>
+                <a:shade val="100000"/>
+              </a:schemeClr>
+            </a:gs>
+            <a:gs pos="100000">
+              <a:schemeClr val="phClr">
+                <a:lumMod val="99000"/>
+                <a:satMod val="120000"/>
+                <a:shade val="78000"/>
+              </a:schemeClr>
+            </a:gs>
+          </a:gsLst>
+          <a:lin ang="5400000" scaled="0"/>
+        </a:gradFill>
+      </a:fillStyleLst>
+      <a:lnStyleLst>
+        <a:ln w="12700" cap="flat" cmpd="sng" algn="ctr">
+          <a:solidFill>
+            <a:schemeClr val="phClr"/>
+          </a:solidFill>
+          <a:prstDash val="solid"/>
+          <a:miter lim="800000"/>
+        </a:ln>
+        <a:ln w="19050" cap="flat" cmpd="sng" algn="ctr">
+          <a:solidFill>
+            <a:schemeClr val="phClr"/>
+          </a:solidFill>
+          <a:prstDash val="solid"/>
+          <a:miter lim="800000"/>
+        </a:ln>
+        <a:ln w="25400" cap="flat" cmpd="sng" algn="ctr">
+          <a:solidFill>
+            <a:schemeClr val="phClr"/>
+          </a:solidFill>
+          <a:prstDash val="solid"/>
+          <a:miter lim="800000"/>
+        </a:ln>
+      </a:lnStyleLst>
+      <a:effectStyleLst>
+        <a:effectStyle>
+          <a:effectLst/>
+        </a:effectStyle>
+        <a:effectStyle>
+          <a:effectLst/>
+        </a:effectStyle>
+        <a:effectStyle>
+          <a:effectLst>
+            <a:outerShdw blurRad="57150" dist="19050" dir="5400000" algn="ctr" rotWithShape="0">
+              <a:srgbClr val="000000">
+                <a:alpha val="63000"/>
+              </a:srgbClr>
+            </a:outerShdw>
+          </a:effectLst>
+        </a:effectStyle>
+      </a:effectStyleLst>
+      <a:bgFillStyleLst>
+        <a:solidFill>
+          <a:schemeClr val="phClr"/>
+        </a:solidFill>
+        <a:solidFill>
+          <a:schemeClr val="phClr">
+            <a:tint val="95000"/>
+            <a:satMod val="170000"/>
+          </a:schemeClr>
+        </a:solidFill>
+        <a:gradFill rotWithShape="1">
+          <a:gsLst>
+            <a:gs pos="0">
+              <a:schemeClr val="phClr">
+                <a:tint val="93000"/>
+                <a:satMod val="150000"/>
+                <a:shade val="98000"/>
+                <a:lumMod val="102000"/>
+              </a:schemeClr>
+            </a:gs>
+            <a:gs pos="50000">
+              <a:schemeClr val="phClr">
+                <a:tint val="98000"/>
+                <a:satMod val="130000"/>
+                <a:shade val="90000"/>
+                <a:lumMod val="103000"/>
+              </a:schemeClr>
+            </a:gs>
+            <a:gs pos="100000">
+              <a:schemeClr val="phClr">
+                <a:shade val="63000"/>
+                <a:satMod val="120000"/>
+              </a:schemeClr>
+            </a:gs>
+          </a:gsLst>
+          <a:lin ang="5400000" scaled="0"/>
+        </a:gradFill>
+      </a:bgFillStyleLst>
+    </a:fmtScheme>
+  </a:themeElements>
+  <a:objectDefaults>
+    <a:lnDef>
+      <a:spPr/>
+      <a:bodyPr/>
+      <a:lstStyle/>
+      <a:style>
+        <a:lnRef idx="2">
+          <a:schemeClr val="accent1"/>
+        </a:lnRef>
+        <a:fillRef idx="0">
+          <a:schemeClr val="accent1"/>
+        </a:fillRef>
+        <a:effectRef idx="1">
+          <a:schemeClr val="accent1"/>
+        </a:effectRef>
+        <a:fontRef idx="minor">
+          <a:schemeClr val="tx1"/>
+        </a:fontRef>
+      </a:style>
+    </a:lnDef>
+  </a:objectDefaults>
+  <a:extraClrSchemeLst/>
+  <a:extLst>
+    <a:ext uri="{05A4C25C-085E-4340-85A3-A5531E510DB2}">
+      <thm15:themeFamily xmlns:thm15="http://schemas.microsoft.com/office/thememl/2012/main" name="Office Theme" id="{2E142A2C-CD16-42D6-873A-C26D2A0506FA}" vid="{1BDDFF52-6CD6-40A5-AB3C-68EB2F1E4D0A}"/>
+    </a:ext>
+  </a:extLst>
+</a:theme>
 </file>
</xml_diff>

<commit_message>
Modules 1 to 3: 'Your week' slide now shows the same eight steps as the site (no Friday); new Module 1 transcript; remove Friday notes
Co-Authored-By: Claude Sonnet 5.5 <noreply@anthropic.com>
Claude-Session: https://claude.ai/code/session_01KXdMXMGRSgMavWy39gk8PG
</commit_message>
<xml_diff>
--- a/downloads/module-1-slides.pptx
+++ b/downloads/module-1-slides.pptx
@@ -1662,14 +1662,14 @@
       </p:sp>
       <p:sp>
         <p:nvSpPr>
-          <p:cNvPr id="5" name="Shape 2"/>
+          <p:cNvPr id="27" name="Shape 2"/>
           <p:cNvSpPr/>
           <p:nvPr/>
         </p:nvSpPr>
         <p:spPr>
           <a:xfrm>
-            <a:off x="822960" y="2194560"/>
-            <a:ext cx="914400" cy="914400"/>
+            <a:off x="822960" y="2011680"/>
+            <a:ext cx="822960" cy="822960"/>
           </a:xfrm>
           <a:prstGeom prst="ellipse">
             <a:avLst/>
@@ -1694,14 +1694,14 @@
       </p:sp>
       <p:sp>
         <p:nvSpPr>
-          <p:cNvPr id="6" name="Text 3"/>
-          <p:cNvSpPr txBox="1"/>
-          <p:nvPr/>
-        </p:nvSpPr>
-        <p:spPr>
-          <a:xfrm>
-            <a:off x="822960" y="2194560"/>
-            <a:ext cx="914400" cy="914400"/>
+          <p:cNvPr id="28" name="Text 3"/>
+          <p:cNvSpPr txBox="1"/>
+          <p:nvPr/>
+        </p:nvSpPr>
+        <p:spPr>
+          <a:xfrm>
+            <a:off x="822960" y="2011680"/>
+            <a:ext cx="822960" cy="822960"/>
           </a:xfrm>
           <a:prstGeom prst="rect">
             <a:avLst/>
@@ -1717,7 +1717,7 @@
               <a:buNone/>
             </a:pPr>
             <a:r>
-              <a:rPr lang="en-US" sz="3000" b="1" dirty="0">
+              <a:rPr lang="en-US" sz="2800" b="1" dirty="0">
                 <a:solidFill>
                   <a:srgbClr val="3B1217"/>
                 </a:solidFill>
@@ -1733,23 +1733,23 @@
       </p:sp>
       <p:sp>
         <p:nvSpPr>
-          <p:cNvPr id="7" name="Text 4"/>
-          <p:cNvSpPr txBox="1"/>
-          <p:nvPr/>
-        </p:nvSpPr>
-        <p:spPr>
-          <a:xfrm>
-            <a:off x="548640" y="3291840"/>
-            <a:ext cx="1463040" cy="822960"/>
-          </a:xfrm>
-          <a:prstGeom prst="rect">
-            <a:avLst/>
-          </a:prstGeom>
-          <a:noFill/>
-          <a:ln/>
-        </p:spPr>
-        <p:txBody>
-          <a:bodyPr wrap="square" lIns="0" tIns="0" rIns="0" bIns="0" rtlCol="0" anchor="ctr"/>
+          <p:cNvPr id="29" name="Text 4"/>
+          <p:cNvSpPr txBox="1"/>
+          <p:nvPr/>
+        </p:nvSpPr>
+        <p:spPr>
+          <a:xfrm>
+            <a:off x="576072" y="2971800"/>
+            <a:ext cx="1316736" cy="1371600"/>
+          </a:xfrm>
+          <a:prstGeom prst="rect">
+            <a:avLst/>
+          </a:prstGeom>
+          <a:noFill/>
+          <a:ln/>
+        </p:spPr>
+        <p:txBody>
+          <a:bodyPr wrap="square" lIns="0" tIns="0" rIns="0" bIns="0" rtlCol="0" anchor="t"/>
           <a:lstStyle/>
           <a:p>
             <a:pPr marL="0" indent="0" algn="ctr">
@@ -1764,7 +1764,7 @@
                 <a:ea typeface="Calibri" pitchFamily="34" charset="-122"/>
                 <a:cs typeface="Calibri" pitchFamily="34" charset="-120"/>
               </a:rPr>
-              <a:t>Try it</a:t>
+              <a:t>Mission brief</a:t>
             </a:r>
             <a:endParaRPr lang="en-US" sz="1600" dirty="0"/>
           </a:p>
@@ -1772,14 +1772,14 @@
       </p:sp>
       <p:sp>
         <p:nvSpPr>
-          <p:cNvPr id="8" name="Shape 5"/>
+          <p:cNvPr id="30" name="Shape 2"/>
           <p:cNvSpPr/>
           <p:nvPr/>
         </p:nvSpPr>
         <p:spPr>
           <a:xfrm>
-            <a:off x="2423160" y="2194560"/>
-            <a:ext cx="914400" cy="914400"/>
+            <a:off x="2194560" y="2011680"/>
+            <a:ext cx="822960" cy="822960"/>
           </a:xfrm>
           <a:prstGeom prst="ellipse">
             <a:avLst/>
@@ -1804,14 +1804,14 @@
       </p:sp>
       <p:sp>
         <p:nvSpPr>
-          <p:cNvPr id="9" name="Text 6"/>
-          <p:cNvSpPr txBox="1"/>
-          <p:nvPr/>
-        </p:nvSpPr>
-        <p:spPr>
-          <a:xfrm>
-            <a:off x="2423160" y="2194560"/>
-            <a:ext cx="914400" cy="914400"/>
+          <p:cNvPr id="31" name="Text 3"/>
+          <p:cNvSpPr txBox="1"/>
+          <p:nvPr/>
+        </p:nvSpPr>
+        <p:spPr>
+          <a:xfrm>
+            <a:off x="2194560" y="2011680"/>
+            <a:ext cx="822960" cy="822960"/>
           </a:xfrm>
           <a:prstGeom prst="rect">
             <a:avLst/>
@@ -1827,7 +1827,7 @@
               <a:buNone/>
             </a:pPr>
             <a:r>
-              <a:rPr lang="en-US" sz="3000" b="1" dirty="0">
+              <a:rPr lang="en-US" sz="2800" b="1" dirty="0">
                 <a:solidFill>
                   <a:srgbClr val="3B1217"/>
                 </a:solidFill>
@@ -1843,23 +1843,23 @@
       </p:sp>
       <p:sp>
         <p:nvSpPr>
-          <p:cNvPr id="10" name="Text 7"/>
-          <p:cNvSpPr txBox="1"/>
-          <p:nvPr/>
-        </p:nvSpPr>
-        <p:spPr>
-          <a:xfrm>
-            <a:off x="2148840" y="3291840"/>
-            <a:ext cx="1463040" cy="822960"/>
-          </a:xfrm>
-          <a:prstGeom prst="rect">
-            <a:avLst/>
-          </a:prstGeom>
-          <a:noFill/>
-          <a:ln/>
-        </p:spPr>
-        <p:txBody>
-          <a:bodyPr wrap="square" lIns="0" tIns="0" rIns="0" bIns="0" rtlCol="0" anchor="ctr"/>
+          <p:cNvPr id="32" name="Text 4"/>
+          <p:cNvSpPr txBox="1"/>
+          <p:nvPr/>
+        </p:nvSpPr>
+        <p:spPr>
+          <a:xfrm>
+            <a:off x="1947672" y="2971800"/>
+            <a:ext cx="1316736" cy="1371600"/>
+          </a:xfrm>
+          <a:prstGeom prst="rect">
+            <a:avLst/>
+          </a:prstGeom>
+          <a:noFill/>
+          <a:ln/>
+        </p:spPr>
+        <p:txBody>
+          <a:bodyPr wrap="square" lIns="0" tIns="0" rIns="0" bIns="0" rtlCol="0" anchor="t"/>
           <a:lstStyle/>
           <a:p>
             <a:pPr marL="0" indent="0" algn="ctr">
@@ -1874,7 +1874,7 @@
                 <a:ea typeface="Calibri" pitchFamily="34" charset="-122"/>
                 <a:cs typeface="Calibri" pitchFamily="34" charset="-120"/>
               </a:rPr>
-              <a:t>Learn</a:t>
+              <a:t>Try it first</a:t>
             </a:r>
             <a:endParaRPr lang="en-US" sz="1600" dirty="0"/>
           </a:p>
@@ -1882,14 +1882,14 @@
       </p:sp>
       <p:sp>
         <p:nvSpPr>
-          <p:cNvPr id="11" name="Shape 8"/>
+          <p:cNvPr id="33" name="Shape 2"/>
           <p:cNvSpPr/>
           <p:nvPr/>
         </p:nvSpPr>
         <p:spPr>
           <a:xfrm>
-            <a:off x="4023360" y="2194560"/>
-            <a:ext cx="914400" cy="914400"/>
+            <a:off x="3566159" y="2011680"/>
+            <a:ext cx="822960" cy="822960"/>
           </a:xfrm>
           <a:prstGeom prst="ellipse">
             <a:avLst/>
@@ -1914,14 +1914,14 @@
       </p:sp>
       <p:sp>
         <p:nvSpPr>
-          <p:cNvPr id="12" name="Text 9"/>
-          <p:cNvSpPr txBox="1"/>
-          <p:nvPr/>
-        </p:nvSpPr>
-        <p:spPr>
-          <a:xfrm>
-            <a:off x="4023360" y="2194560"/>
-            <a:ext cx="914400" cy="914400"/>
+          <p:cNvPr id="34" name="Text 3"/>
+          <p:cNvSpPr txBox="1"/>
+          <p:nvPr/>
+        </p:nvSpPr>
+        <p:spPr>
+          <a:xfrm>
+            <a:off x="3566159" y="2011680"/>
+            <a:ext cx="822960" cy="822960"/>
           </a:xfrm>
           <a:prstGeom prst="rect">
             <a:avLst/>
@@ -1937,7 +1937,7 @@
               <a:buNone/>
             </a:pPr>
             <a:r>
-              <a:rPr lang="en-US" sz="3000" b="1" dirty="0">
+              <a:rPr lang="en-US" sz="2800" b="1" dirty="0">
                 <a:solidFill>
                   <a:srgbClr val="3B1217"/>
                 </a:solidFill>
@@ -1953,23 +1953,23 @@
       </p:sp>
       <p:sp>
         <p:nvSpPr>
-          <p:cNvPr id="13" name="Text 10"/>
-          <p:cNvSpPr txBox="1"/>
-          <p:nvPr/>
-        </p:nvSpPr>
-        <p:spPr>
-          <a:xfrm>
-            <a:off x="3749040" y="3291840"/>
-            <a:ext cx="1463040" cy="822960"/>
-          </a:xfrm>
-          <a:prstGeom prst="rect">
-            <a:avLst/>
-          </a:prstGeom>
-          <a:noFill/>
-          <a:ln/>
-        </p:spPr>
-        <p:txBody>
-          <a:bodyPr wrap="square" lIns="0" tIns="0" rIns="0" bIns="0" rtlCol="0" anchor="ctr"/>
+          <p:cNvPr id="35" name="Text 4"/>
+          <p:cNvSpPr txBox="1"/>
+          <p:nvPr/>
+        </p:nvSpPr>
+        <p:spPr>
+          <a:xfrm>
+            <a:off x="3319272" y="2971800"/>
+            <a:ext cx="1316736" cy="1371600"/>
+          </a:xfrm>
+          <a:prstGeom prst="rect">
+            <a:avLst/>
+          </a:prstGeom>
+          <a:noFill/>
+          <a:ln/>
+        </p:spPr>
+        <p:txBody>
+          <a:bodyPr wrap="square" lIns="0" tIns="0" rIns="0" bIns="0" rtlCol="0" anchor="t"/>
           <a:lstStyle/>
           <a:p>
             <a:pPr marL="0" indent="0" algn="ctr">
@@ -1984,7 +1984,7 @@
                 <a:ea typeface="Calibri" pitchFamily="34" charset="-122"/>
                 <a:cs typeface="Calibri" pitchFamily="34" charset="-120"/>
               </a:rPr>
-              <a:t>Ethics</a:t>
+              <a:t>Learn</a:t>
             </a:r>
             <a:endParaRPr lang="en-US" sz="1600" dirty="0"/>
           </a:p>
@@ -1992,14 +1992,14 @@
       </p:sp>
       <p:sp>
         <p:nvSpPr>
-          <p:cNvPr id="14" name="Shape 11"/>
+          <p:cNvPr id="36" name="Shape 2"/>
           <p:cNvSpPr/>
           <p:nvPr/>
         </p:nvSpPr>
         <p:spPr>
           <a:xfrm>
-            <a:off x="5623560" y="2194560"/>
-            <a:ext cx="914400" cy="914400"/>
+            <a:off x="4937759" y="2011680"/>
+            <a:ext cx="822960" cy="822960"/>
           </a:xfrm>
           <a:prstGeom prst="ellipse">
             <a:avLst/>
@@ -2024,14 +2024,14 @@
       </p:sp>
       <p:sp>
         <p:nvSpPr>
-          <p:cNvPr id="15" name="Text 12"/>
-          <p:cNvSpPr txBox="1"/>
-          <p:nvPr/>
-        </p:nvSpPr>
-        <p:spPr>
-          <a:xfrm>
-            <a:off x="5623560" y="2194560"/>
-            <a:ext cx="914400" cy="914400"/>
+          <p:cNvPr id="37" name="Text 3"/>
+          <p:cNvSpPr txBox="1"/>
+          <p:nvPr/>
+        </p:nvSpPr>
+        <p:spPr>
+          <a:xfrm>
+            <a:off x="4937759" y="2011680"/>
+            <a:ext cx="822960" cy="822960"/>
           </a:xfrm>
           <a:prstGeom prst="rect">
             <a:avLst/>
@@ -2047,7 +2047,7 @@
               <a:buNone/>
             </a:pPr>
             <a:r>
-              <a:rPr lang="en-US" sz="3000" b="1" dirty="0">
+              <a:rPr lang="en-US" sz="2800" b="1" dirty="0">
                 <a:solidFill>
                   <a:srgbClr val="3B1217"/>
                 </a:solidFill>
@@ -2063,23 +2063,23 @@
       </p:sp>
       <p:sp>
         <p:nvSpPr>
-          <p:cNvPr id="16" name="Text 13"/>
-          <p:cNvSpPr txBox="1"/>
-          <p:nvPr/>
-        </p:nvSpPr>
-        <p:spPr>
-          <a:xfrm>
-            <a:off x="5349240" y="3291840"/>
-            <a:ext cx="1463040" cy="822960"/>
-          </a:xfrm>
-          <a:prstGeom prst="rect">
-            <a:avLst/>
-          </a:prstGeom>
-          <a:noFill/>
-          <a:ln/>
-        </p:spPr>
-        <p:txBody>
-          <a:bodyPr wrap="square" lIns="0" tIns="0" rIns="0" bIns="0" rtlCol="0" anchor="ctr"/>
+          <p:cNvPr id="38" name="Text 4"/>
+          <p:cNvSpPr txBox="1"/>
+          <p:nvPr/>
+        </p:nvSpPr>
+        <p:spPr>
+          <a:xfrm>
+            <a:off x="4690872" y="2971800"/>
+            <a:ext cx="1316736" cy="1371600"/>
+          </a:xfrm>
+          <a:prstGeom prst="rect">
+            <a:avLst/>
+          </a:prstGeom>
+          <a:noFill/>
+          <a:ln/>
+        </p:spPr>
+        <p:txBody>
+          <a:bodyPr wrap="square" lIns="0" tIns="0" rIns="0" bIns="0" rtlCol="0" anchor="t"/>
           <a:lstStyle/>
           <a:p>
             <a:pPr marL="0" indent="0" algn="ctr">
@@ -2094,7 +2094,7 @@
                 <a:ea typeface="Calibri" pitchFamily="34" charset="-122"/>
                 <a:cs typeface="Calibri" pitchFamily="34" charset="-120"/>
               </a:rPr>
-              <a:t>Attempt + coach</a:t>
+              <a:t>Ethics checkpoint</a:t>
             </a:r>
             <a:endParaRPr lang="en-US" sz="1600" dirty="0"/>
           </a:p>
@@ -2102,14 +2102,14 @@
       </p:sp>
       <p:sp>
         <p:nvSpPr>
-          <p:cNvPr id="17" name="Shape 14"/>
+          <p:cNvPr id="39" name="Shape 2"/>
           <p:cNvSpPr/>
           <p:nvPr/>
         </p:nvSpPr>
         <p:spPr>
           <a:xfrm>
-            <a:off x="7223760" y="2194560"/>
-            <a:ext cx="914400" cy="914400"/>
+            <a:off x="6309359" y="2011680"/>
+            <a:ext cx="822960" cy="822960"/>
           </a:xfrm>
           <a:prstGeom prst="ellipse">
             <a:avLst/>
@@ -2134,14 +2134,14 @@
       </p:sp>
       <p:sp>
         <p:nvSpPr>
-          <p:cNvPr id="18" name="Text 15"/>
-          <p:cNvSpPr txBox="1"/>
-          <p:nvPr/>
-        </p:nvSpPr>
-        <p:spPr>
-          <a:xfrm>
-            <a:off x="7223760" y="2194560"/>
-            <a:ext cx="914400" cy="914400"/>
+          <p:cNvPr id="40" name="Text 3"/>
+          <p:cNvSpPr txBox="1"/>
+          <p:nvPr/>
+        </p:nvSpPr>
+        <p:spPr>
+          <a:xfrm>
+            <a:off x="6309359" y="2011680"/>
+            <a:ext cx="822960" cy="822960"/>
           </a:xfrm>
           <a:prstGeom prst="rect">
             <a:avLst/>
@@ -2157,7 +2157,7 @@
               <a:buNone/>
             </a:pPr>
             <a:r>
-              <a:rPr lang="en-US" sz="3000" b="1" dirty="0">
+              <a:rPr lang="en-US" sz="2800" b="1" dirty="0">
                 <a:solidFill>
                   <a:srgbClr val="3B1217"/>
                 </a:solidFill>
@@ -2173,23 +2173,23 @@
       </p:sp>
       <p:sp>
         <p:nvSpPr>
-          <p:cNvPr id="19" name="Text 16"/>
-          <p:cNvSpPr txBox="1"/>
-          <p:nvPr/>
-        </p:nvSpPr>
-        <p:spPr>
-          <a:xfrm>
-            <a:off x="6949440" y="3291840"/>
-            <a:ext cx="1463040" cy="822960"/>
-          </a:xfrm>
-          <a:prstGeom prst="rect">
-            <a:avLst/>
-          </a:prstGeom>
-          <a:noFill/>
-          <a:ln/>
-        </p:spPr>
-        <p:txBody>
-          <a:bodyPr wrap="square" lIns="0" tIns="0" rIns="0" bIns="0" rtlCol="0" anchor="ctr"/>
+          <p:cNvPr id="41" name="Text 4"/>
+          <p:cNvSpPr txBox="1"/>
+          <p:nvPr/>
+        </p:nvSpPr>
+        <p:spPr>
+          <a:xfrm>
+            <a:off x="6062472" y="2971800"/>
+            <a:ext cx="1316736" cy="1371600"/>
+          </a:xfrm>
+          <a:prstGeom prst="rect">
+            <a:avLst/>
+          </a:prstGeom>
+          <a:noFill/>
+          <a:ln/>
+        </p:spPr>
+        <p:txBody>
+          <a:bodyPr wrap="square" lIns="0" tIns="0" rIns="0" bIns="0" rtlCol="0" anchor="t"/>
           <a:lstStyle/>
           <a:p>
             <a:pPr marL="0" indent="0" algn="ctr">
@@ -2204,7 +2204,7 @@
                 <a:ea typeface="Calibri" pitchFamily="34" charset="-122"/>
                 <a:cs typeface="Calibri" pitchFamily="34" charset="-120"/>
               </a:rPr>
-              <a:t>Mastery</a:t>
+              <a:t>First attempt and coach feedback</a:t>
             </a:r>
             <a:endParaRPr lang="en-US" sz="1600" dirty="0"/>
           </a:p>
@@ -2212,14 +2212,14 @@
       </p:sp>
       <p:sp>
         <p:nvSpPr>
-          <p:cNvPr id="20" name="Shape 17"/>
+          <p:cNvPr id="42" name="Shape 2"/>
           <p:cNvSpPr/>
           <p:nvPr/>
         </p:nvSpPr>
         <p:spPr>
           <a:xfrm>
-            <a:off x="8823960" y="2194560"/>
-            <a:ext cx="914400" cy="914400"/>
+            <a:off x="7680960" y="2011680"/>
+            <a:ext cx="822960" cy="822960"/>
           </a:xfrm>
           <a:prstGeom prst="ellipse">
             <a:avLst/>
@@ -2244,14 +2244,14 @@
       </p:sp>
       <p:sp>
         <p:nvSpPr>
-          <p:cNvPr id="21" name="Text 18"/>
-          <p:cNvSpPr txBox="1"/>
-          <p:nvPr/>
-        </p:nvSpPr>
-        <p:spPr>
-          <a:xfrm>
-            <a:off x="8823960" y="2194560"/>
-            <a:ext cx="914400" cy="914400"/>
+          <p:cNvPr id="43" name="Text 3"/>
+          <p:cNvSpPr txBox="1"/>
+          <p:nvPr/>
+        </p:nvSpPr>
+        <p:spPr>
+          <a:xfrm>
+            <a:off x="7680960" y="2011680"/>
+            <a:ext cx="822960" cy="822960"/>
           </a:xfrm>
           <a:prstGeom prst="rect">
             <a:avLst/>
@@ -2267,7 +2267,7 @@
               <a:buNone/>
             </a:pPr>
             <a:r>
-              <a:rPr lang="en-US" sz="3000" b="1" dirty="0">
+              <a:rPr lang="en-US" sz="2800" b="1" dirty="0">
                 <a:solidFill>
                   <a:srgbClr val="3B1217"/>
                 </a:solidFill>
@@ -2283,23 +2283,23 @@
       </p:sp>
       <p:sp>
         <p:nvSpPr>
-          <p:cNvPr id="22" name="Text 19"/>
-          <p:cNvSpPr txBox="1"/>
-          <p:nvPr/>
-        </p:nvSpPr>
-        <p:spPr>
-          <a:xfrm>
-            <a:off x="8549640" y="3291840"/>
-            <a:ext cx="1463040" cy="822960"/>
-          </a:xfrm>
-          <a:prstGeom prst="rect">
-            <a:avLst/>
-          </a:prstGeom>
-          <a:noFill/>
-          <a:ln/>
-        </p:spPr>
-        <p:txBody>
-          <a:bodyPr wrap="square" lIns="0" tIns="0" rIns="0" bIns="0" rtlCol="0" anchor="ctr"/>
+          <p:cNvPr id="44" name="Text 4"/>
+          <p:cNvSpPr txBox="1"/>
+          <p:nvPr/>
+        </p:nvSpPr>
+        <p:spPr>
+          <a:xfrm>
+            <a:off x="7434071" y="2971800"/>
+            <a:ext cx="1316736" cy="1371600"/>
+          </a:xfrm>
+          <a:prstGeom prst="rect">
+            <a:avLst/>
+          </a:prstGeom>
+          <a:noFill/>
+          <a:ln/>
+        </p:spPr>
+        <p:txBody>
+          <a:bodyPr wrap="square" lIns="0" tIns="0" rIns="0" bIns="0" rtlCol="0" anchor="t"/>
           <a:lstStyle/>
           <a:p>
             <a:pPr marL="0" indent="0" algn="ctr">
@@ -2314,7 +2314,7 @@
                 <a:ea typeface="Calibri" pitchFamily="34" charset="-122"/>
                 <a:cs typeface="Calibri" pitchFamily="34" charset="-120"/>
               </a:rPr>
-              <a:t>Quiz</a:t>
+              <a:t>Mastery attempt</a:t>
             </a:r>
             <a:endParaRPr lang="en-US" sz="1600" dirty="0"/>
           </a:p>
@@ -2322,14 +2322,14 @@
       </p:sp>
       <p:sp>
         <p:nvSpPr>
-          <p:cNvPr id="23" name="Shape 20"/>
+          <p:cNvPr id="45" name="Shape 2"/>
           <p:cNvSpPr/>
           <p:nvPr/>
         </p:nvSpPr>
         <p:spPr>
           <a:xfrm>
-            <a:off x="10424160" y="2194560"/>
-            <a:ext cx="914400" cy="914400"/>
+            <a:off x="9052560" y="2011680"/>
+            <a:ext cx="822960" cy="822960"/>
           </a:xfrm>
           <a:prstGeom prst="ellipse">
             <a:avLst/>
@@ -2354,14 +2354,14 @@
       </p:sp>
       <p:sp>
         <p:nvSpPr>
-          <p:cNvPr id="24" name="Text 21"/>
-          <p:cNvSpPr txBox="1"/>
-          <p:nvPr/>
-        </p:nvSpPr>
-        <p:spPr>
-          <a:xfrm>
-            <a:off x="10424160" y="2194560"/>
-            <a:ext cx="914400" cy="914400"/>
+          <p:cNvPr id="46" name="Text 3"/>
+          <p:cNvSpPr txBox="1"/>
+          <p:nvPr/>
+        </p:nvSpPr>
+        <p:spPr>
+          <a:xfrm>
+            <a:off x="9052560" y="2011680"/>
+            <a:ext cx="822960" cy="822960"/>
           </a:xfrm>
           <a:prstGeom prst="rect">
             <a:avLst/>
@@ -2377,7 +2377,7 @@
               <a:buNone/>
             </a:pPr>
             <a:r>
-              <a:rPr lang="en-US" sz="3000" b="1" dirty="0">
+              <a:rPr lang="en-US" sz="2800" b="1" dirty="0">
                 <a:solidFill>
                   <a:srgbClr val="3B1217"/>
                 </a:solidFill>
@@ -2393,23 +2393,23 @@
       </p:sp>
       <p:sp>
         <p:nvSpPr>
-          <p:cNvPr id="25" name="Text 22"/>
-          <p:cNvSpPr txBox="1"/>
-          <p:nvPr/>
-        </p:nvSpPr>
-        <p:spPr>
-          <a:xfrm>
-            <a:off x="10149840" y="3291840"/>
-            <a:ext cx="1463040" cy="822960"/>
-          </a:xfrm>
-          <a:prstGeom prst="rect">
-            <a:avLst/>
-          </a:prstGeom>
-          <a:noFill/>
-          <a:ln/>
-        </p:spPr>
-        <p:txBody>
-          <a:bodyPr wrap="square" lIns="0" tIns="0" rIns="0" bIns="0" rtlCol="0" anchor="ctr"/>
+          <p:cNvPr id="47" name="Text 4"/>
+          <p:cNvSpPr txBox="1"/>
+          <p:nvPr/>
+        </p:nvSpPr>
+        <p:spPr>
+          <a:xfrm>
+            <a:off x="8805672" y="2971800"/>
+            <a:ext cx="1316736" cy="1371600"/>
+          </a:xfrm>
+          <a:prstGeom prst="rect">
+            <a:avLst/>
+          </a:prstGeom>
+          <a:noFill/>
+          <a:ln/>
+        </p:spPr>
+        <p:txBody>
+          <a:bodyPr wrap="square" lIns="0" tIns="0" rIns="0" bIns="0" rtlCol="0" anchor="t"/>
           <a:lstStyle/>
           <a:p>
             <a:pPr marL="0" indent="0" algn="ctr">
@@ -2424,7 +2424,7 @@
                 <a:ea typeface="Calibri" pitchFamily="34" charset="-122"/>
                 <a:cs typeface="Calibri" pitchFamily="34" charset="-120"/>
               </a:rPr>
-              <a:t>Reflect</a:t>
+              <a:t>Quiz</a:t>
             </a:r>
             <a:endParaRPr lang="en-US" sz="1600" dirty="0"/>
           </a:p>
@@ -2432,14 +2432,46 @@
       </p:sp>
       <p:sp>
         <p:nvSpPr>
-          <p:cNvPr id="26" name="Text 23"/>
-          <p:cNvSpPr txBox="1"/>
-          <p:nvPr/>
-        </p:nvSpPr>
-        <p:spPr>
-          <a:xfrm>
-            <a:off x="548640" y="4846320"/>
-            <a:ext cx="10972800" cy="640080"/>
+          <p:cNvPr id="48" name="Shape 2"/>
+          <p:cNvSpPr/>
+          <p:nvPr/>
+        </p:nvSpPr>
+        <p:spPr>
+          <a:xfrm>
+            <a:off x="10424160" y="2011680"/>
+            <a:ext cx="822960" cy="822960"/>
+          </a:xfrm>
+          <a:prstGeom prst="ellipse">
+            <a:avLst/>
+          </a:prstGeom>
+          <a:solidFill>
+            <a:srgbClr val="F1BE48"/>
+          </a:solidFill>
+          <a:ln w="12700">
+            <a:solidFill>
+              <a:srgbClr val="F1BE48"/>
+            </a:solidFill>
+            <a:prstDash val="solid"/>
+          </a:ln>
+        </p:spPr>
+        <p:txBody>
+          <a:bodyPr/>
+          <a:lstStyle/>
+          <a:p>
+            <a:endParaRPr lang="en-US"/>
+          </a:p>
+        </p:txBody>
+      </p:sp>
+      <p:sp>
+        <p:nvSpPr>
+          <p:cNvPr id="49" name="Text 3"/>
+          <p:cNvSpPr txBox="1"/>
+          <p:nvPr/>
+        </p:nvSpPr>
+        <p:spPr>
+          <a:xfrm>
+            <a:off x="10424160" y="2011680"/>
+            <a:ext cx="822960" cy="822960"/>
           </a:xfrm>
           <a:prstGeom prst="rect">
             <a:avLst/>
@@ -2451,19 +2483,97 @@
           <a:bodyPr wrap="square" lIns="0" tIns="0" rIns="0" bIns="0" rtlCol="0" anchor="ctr"/>
           <a:lstStyle/>
           <a:p>
-            <a:pPr marL="0" indent="0">
-              <a:buNone/>
-            </a:pPr>
-            <a:r>
-              <a:rPr lang="en-US" sz="3000" b="1" dirty="0">
-                <a:solidFill>
-                  <a:srgbClr val="FFFFFF"/>
+            <a:pPr marL="0" indent="0" algn="ctr">
+              <a:buNone/>
+            </a:pPr>
+            <a:r>
+              <a:rPr lang="en-US" sz="2800" b="1" dirty="0">
+                <a:solidFill>
+                  <a:srgbClr val="3B1217"/>
                 </a:solidFill>
                 <a:latin typeface="Cambria" pitchFamily="34" charset="0"/>
                 <a:ea typeface="Cambria" pitchFamily="34" charset="-122"/>
                 <a:cs typeface="Cambria" pitchFamily="34" charset="-120"/>
               </a:rPr>
-              <a:t>By Friday: a memo Priya can act on.</a:t>
+              <a:t>8</a:t>
+            </a:r>
+            <a:endParaRPr lang="en-US" sz="3000" dirty="0"/>
+          </a:p>
+        </p:txBody>
+      </p:sp>
+      <p:sp>
+        <p:nvSpPr>
+          <p:cNvPr id="50" name="Text 4"/>
+          <p:cNvSpPr txBox="1"/>
+          <p:nvPr/>
+        </p:nvSpPr>
+        <p:spPr>
+          <a:xfrm>
+            <a:off x="10177272" y="2971800"/>
+            <a:ext cx="1316736" cy="1371600"/>
+          </a:xfrm>
+          <a:prstGeom prst="rect">
+            <a:avLst/>
+          </a:prstGeom>
+          <a:noFill/>
+          <a:ln/>
+        </p:spPr>
+        <p:txBody>
+          <a:bodyPr wrap="square" lIns="0" tIns="0" rIns="0" bIns="0" rtlCol="0" anchor="t"/>
+          <a:lstStyle/>
+          <a:p>
+            <a:pPr marL="0" indent="0" algn="ctr">
+              <a:buNone/>
+            </a:pPr>
+            <a:r>
+              <a:rPr lang="en-US" sz="1600" b="1" dirty="0">
+                <a:solidFill>
+                  <a:srgbClr val="FFFFFF"/>
+                </a:solidFill>
+                <a:latin typeface="Calibri" pitchFamily="34" charset="0"/>
+                <a:ea typeface="Calibri" pitchFamily="34" charset="-122"/>
+                <a:cs typeface="Calibri" pitchFamily="34" charset="-120"/>
+              </a:rPr>
+              <a:t>Reflection</a:t>
+            </a:r>
+            <a:endParaRPr lang="en-US" sz="1600" dirty="0"/>
+          </a:p>
+        </p:txBody>
+      </p:sp>
+      <p:sp>
+        <p:nvSpPr>
+          <p:cNvPr id="26" name="Text 23"/>
+          <p:cNvSpPr txBox="1"/>
+          <p:nvPr/>
+        </p:nvSpPr>
+        <p:spPr>
+          <a:xfrm>
+            <a:off x="548640" y="4846320"/>
+            <a:ext cx="10972800" cy="640080"/>
+          </a:xfrm>
+          <a:prstGeom prst="rect">
+            <a:avLst/>
+          </a:prstGeom>
+          <a:noFill/>
+          <a:ln/>
+        </p:spPr>
+        <p:txBody>
+          <a:bodyPr wrap="square" lIns="0" tIns="0" rIns="0" bIns="0" rtlCol="0" anchor="ctr"/>
+          <a:lstStyle/>
+          <a:p>
+            <a:pPr marL="0" indent="0">
+              <a:buNone/>
+            </a:pPr>
+            <a:r>
+              <a:rPr lang="en-US" sz="3000" b="1" dirty="0">
+                <a:solidFill>
+                  <a:srgbClr val="FFFFFF"/>
+                </a:solidFill>
+                <a:latin typeface="Cambria" pitchFamily="34" charset="0"/>
+                <a:ea typeface="Cambria" pitchFamily="34" charset="-122"/>
+                <a:cs typeface="Cambria" pitchFamily="34" charset="-120"/>
+              </a:rPr>
+              <a:t>Your goal: a memo Priya can act on.</a:t>
             </a:r>
             <a:endParaRPr lang="en-US" sz="3000" dirty="0"/>
           </a:p>

</xml_diff>